<commit_message>
Align deck with Unit 15 proposal framework: sizing, VaR/ES, stress, exits
Co-Authored-By: Claude Opus 5.5 <noreply@anthropic.com>
Claude-Session: https://claude.ai/code/session_01SKXMSdhUJkGhAWrJ1jHvDm
</commit_message>
<xml_diff>
--- a/deck/K-Dislocation-Note.pptx
+++ b/deck/K-Dislocation-Note.pptx
@@ -1922,7 +1922,7 @@
           <a:p>
             <a:r>
               <a:rPr lang="en-US" dirty="0"/>
-              <a:t>Be candid: the 2022 path is the bad case for Engine A. The cap is what protects the fund. Show stress-test P&amp;L in the appendix.</a:t>
+              <a:t>Unit 15: size off the contractual loss, show the division. VaR with all three parameters (10-day, 99%, delta-normal) plus ES. Stress moves spot and vol together. Script: pricing/risk_metrics.py.</a:t>
             </a:r>
             <a:endParaRPr lang="en-US" dirty="0"/>
           </a:p>
@@ -2010,7 +2010,7 @@
           <a:p>
             <a:r>
               <a:rPr lang="en-US" dirty="0"/>
-              <a:t>Close on fit: exotic, asymmetric, trustworthy. Ask for the next meeting.</a:t>
+              <a:t>Unit 15: all four exits. On a long-convexity note a stop-loss does not limit loss; the max loss is already contractual. Thesis invalidation is the most professional exit.</a:t>
             </a:r>
             <a:endParaRPr lang="en-US" dirty="0"/>
           </a:p>
@@ -2098,7 +2098,7 @@
           <a:p>
             <a:r>
               <a:rPr lang="en-US" dirty="0"/>
-              <a:t>Appendix. Pricing script: pricing/illustrative_mc.py in the team repo.</a:t>
+              <a:t>Appendix. Scripts: pricing/illustrative_mc.py and pricing/risk_metrics.py.</a:t>
             </a:r>
             <a:endParaRPr lang="en-US" dirty="0"/>
           </a:p>
@@ -3552,7 +3552,7 @@
                 <a:ea typeface="Calibri" pitchFamily="34" charset="-122"/>
                 <a:cs typeface="Calibri" pitchFamily="34" charset="-120"/>
               </a:rPr>
-              <a:t>Oil shock, KOSPI +20% from trigger</a:t>
+              <a:t>Base: oil shock, KOSPI +20% from trigger</a:t>
             </a:r>
             <a:endParaRPr lang="en-US" sz="1200" dirty="0"/>
           </a:p>
@@ -3650,7 +3650,7 @@
                 <a:ea typeface="Calibri" pitchFamily="34" charset="-122"/>
                 <a:cs typeface="Calibri" pitchFamily="34" charset="-120"/>
               </a:rPr>
-              <a:t>Oil shock, KRW resilient, rebound</a:t>
+              <a:t>Best: oil shock, KRW resilient, rebound</a:t>
             </a:r>
             <a:endParaRPr lang="en-US" sz="1200" dirty="0"/>
           </a:p>
@@ -3748,7 +3748,7 @@
                 <a:ea typeface="Calibri" pitchFamily="34" charset="-122"/>
                 <a:cs typeface="Calibri" pitchFamily="34" charset="-120"/>
               </a:rPr>
-              <a:t>Ceasefire and re-rating</a:t>
+              <a:t>Alternative: ceasefire and re-rating</a:t>
             </a:r>
             <a:endParaRPr lang="en-US" sz="1200" dirty="0"/>
           </a:p>
@@ -3846,7 +3846,7 @@
                 <a:ea typeface="Calibri" pitchFamily="34" charset="-122"/>
                 <a:cs typeface="Calibri" pitchFamily="34" charset="-120"/>
               </a:rPr>
-              <a:t>Flat markets, or no rebound after shock</a:t>
+              <a:t>Worst: flat, or no rebound after shock</a:t>
             </a:r>
             <a:endParaRPr lang="en-US" sz="1200" dirty="0"/>
           </a:p>
@@ -3885,7 +3885,7 @@
                 <a:ea typeface="Calibri" pitchFamily="34" charset="-122"/>
                 <a:cs typeface="Calibri" pitchFamily="34" charset="-120"/>
               </a:rPr>
-              <a:t>Capped at −10%</a:t>
+              <a:t>Capped at −10% at maturity</a:t>
             </a:r>
             <a:endParaRPr lang="en-US" sz="1150" dirty="0"/>
           </a:p>
@@ -4034,7 +4034,7 @@
                 <a:ea typeface="Cambria" pitchFamily="34" charset="-122"/>
                 <a:cs typeface="Cambria" pitchFamily="34" charset="-120"/>
               </a:rPr>
-              <a:t>Risks we disclose and manage</a:t>
+              <a:t>Sizing and market risk</a:t>
             </a:r>
             <a:endParaRPr lang="en-US" sz="2800" dirty="0"/>
           </a:p>
@@ -4073,9 +4073,277 @@
                 <a:ea typeface="Calibri" pitchFamily="34" charset="-122"/>
                 <a:cs typeface="Calibri" pitchFamily="34" charset="-120"/>
               </a:rPr>
-              <a:t>Stress tests use a level shift: whole vol surface +5 to +15 pts with spot down (Unit 4)</a:t>
+              <a:t>Unit 15 sizing identity, VaR / ES, and stress tests with spot and vol shocked together</a:t>
             </a:r>
             <a:endParaRPr lang="en-US" sz="1300" dirty="0"/>
+          </a:p>
+        </p:txBody>
+      </p:sp>
+      <p:sp>
+        <p:nvSpPr>
+          <p:cNvPr id="4" name="Shape 2"/>
+          <p:cNvSpPr/>
+          <p:nvPr/>
+        </p:nvSpPr>
+        <p:spPr>
+          <a:xfrm>
+            <a:off x="457200" y="1280160"/>
+            <a:ext cx="2743200" cy="3337560"/>
+          </a:xfrm>
+          <a:prstGeom prst="roundRect">
+            <a:avLst>
+              <a:gd name="adj" fmla="val 2667"/>
+            </a:avLst>
+          </a:prstGeom>
+          <a:solidFill>
+            <a:srgbClr val="2A1650"/>
+          </a:solidFill>
+          <a:ln w="12700">
+            <a:solidFill>
+              <a:srgbClr val="2A1650"/>
+            </a:solidFill>
+            <a:prstDash val="solid"/>
+          </a:ln>
+        </p:spPr>
+      </p:sp>
+      <p:sp>
+        <p:nvSpPr>
+          <p:cNvPr id="5" name="Text 3"/>
+          <p:cNvSpPr txBox="1"/>
+          <p:nvPr/>
+        </p:nvSpPr>
+        <p:spPr>
+          <a:xfrm>
+            <a:off x="640080" y="1371600"/>
+            <a:ext cx="2377440" cy="320040"/>
+          </a:xfrm>
+          <a:prstGeom prst="rect">
+            <a:avLst/>
+          </a:prstGeom>
+          <a:noFill/>
+          <a:ln/>
+        </p:spPr>
+        <p:txBody>
+          <a:bodyPr wrap="square" lIns="0" tIns="0" rIns="0" bIns="0" rtlCol="0" anchor="ctr"/>
+          <a:lstStyle/>
+          <a:p>
+            <a:pPr indent="0" marL="0">
+              <a:buNone/>
+            </a:pPr>
+            <a:r>
+              <a:rPr lang="en-US" sz="1400" b="1" dirty="0">
+                <a:solidFill>
+                  <a:srgbClr val="E8A33D"/>
+                </a:solidFill>
+                <a:latin typeface="Cambria" pitchFamily="34" charset="0"/>
+                <a:ea typeface="Cambria" pitchFamily="34" charset="-122"/>
+                <a:cs typeface="Cambria" pitchFamily="34" charset="-120"/>
+              </a:rPr>
+              <a:t>Sizing identity</a:t>
+            </a:r>
+            <a:endParaRPr lang="en-US" sz="1400" dirty="0"/>
+          </a:p>
+        </p:txBody>
+      </p:sp>
+      <p:sp>
+        <p:nvSpPr>
+          <p:cNvPr id="6" name="Text 4"/>
+          <p:cNvSpPr txBox="1"/>
+          <p:nvPr/>
+        </p:nvSpPr>
+        <p:spPr>
+          <a:xfrm>
+            <a:off x="640080" y="1737360"/>
+            <a:ext cx="2377440" cy="1554480"/>
+          </a:xfrm>
+          <a:prstGeom prst="rect">
+            <a:avLst/>
+          </a:prstGeom>
+          <a:noFill/>
+          <a:ln/>
+        </p:spPr>
+        <p:txBody>
+          <a:bodyPr wrap="square" lIns="0" tIns="0" rIns="0" bIns="0" rtlCol="0" anchor="t"/>
+          <a:lstStyle/>
+          <a:p>
+            <a:pPr indent="0" marL="0">
+              <a:buNone/>
+            </a:pPr>
+            <a:r>
+              <a:rPr lang="en-US" sz="1150" dirty="0">
+                <a:solidFill>
+                  <a:srgbClr val="FFFFFF"/>
+                </a:solidFill>
+                <a:latin typeface="Calibri" pitchFamily="34" charset="0"/>
+                <a:ea typeface="Calibri" pitchFamily="34" charset="-122"/>
+                <a:cs typeface="Calibri" pitchFamily="34" charset="-120"/>
+              </a:rPr>
+              <a:t>Risk budget: 25 bp of USD 10bn AUM</a:t>
+            </a:r>
+            <a:endParaRPr lang="en-US" sz="1150" dirty="0"/>
+          </a:p>
+          <a:p>
+            <a:pPr indent="0" marL="0">
+              <a:buNone/>
+            </a:pPr>
+            <a:r>
+              <a:rPr lang="en-US" sz="1150" b="1" dirty="0">
+                <a:solidFill>
+                  <a:srgbClr val="FFFFFF"/>
+                </a:solidFill>
+                <a:latin typeface="Calibri" pitchFamily="34" charset="0"/>
+                <a:ea typeface="Calibri" pitchFamily="34" charset="-122"/>
+                <a:cs typeface="Calibri" pitchFamily="34" charset="-120"/>
+              </a:rPr>
+              <a:t>= USD 25M</a:t>
+            </a:r>
+            <a:endParaRPr lang="en-US" sz="1150" dirty="0"/>
+          </a:p>
+          <a:p>
+            <a:pPr indent="0" marL="0">
+              <a:buNone/>
+            </a:pPr>
+            <a:r>
+              <a:rPr lang="en-US" sz="1150" dirty="0">
+                <a:solidFill>
+                  <a:srgbClr val="FFFFFF"/>
+                </a:solidFill>
+                <a:latin typeface="Calibri" pitchFamily="34" charset="0"/>
+                <a:ea typeface="Calibri" pitchFamily="34" charset="-122"/>
+                <a:cs typeface="Calibri" pitchFamily="34" charset="-120"/>
+              </a:rPr>
+              <a:t>Loss per unit: 10% of notional</a:t>
+            </a:r>
+            <a:endParaRPr lang="en-US" sz="1150" dirty="0"/>
+          </a:p>
+          <a:p>
+            <a:pPr indent="0" marL="0">
+              <a:buNone/>
+            </a:pPr>
+            <a:r>
+              <a:rPr lang="en-US" sz="1150" i="1" dirty="0">
+                <a:solidFill>
+                  <a:srgbClr val="FFFFFF"/>
+                </a:solidFill>
+                <a:latin typeface="Calibri" pitchFamily="34" charset="0"/>
+                <a:ea typeface="Calibri" pitchFamily="34" charset="-122"/>
+                <a:cs typeface="Calibri" pitchFamily="34" charset="-120"/>
+              </a:rPr>
+              <a:t>(contractual, held to maturity)</a:t>
+            </a:r>
+            <a:endParaRPr lang="en-US" sz="1150" dirty="0"/>
+          </a:p>
+          <a:p>
+            <a:pPr indent="0" marL="0">
+              <a:buNone/>
+            </a:pPr>
+            <a:r>
+              <a:rPr lang="en-US" sz="1150" dirty="0">
+                <a:solidFill>
+                  <a:srgbClr val="FFFFFF"/>
+                </a:solidFill>
+                <a:latin typeface="Calibri" pitchFamily="34" charset="0"/>
+                <a:ea typeface="Calibri" pitchFamily="34" charset="-122"/>
+                <a:cs typeface="Calibri" pitchFamily="34" charset="-120"/>
+              </a:rPr>
+              <a:t>Max notional = 25M ÷ 10%</a:t>
+            </a:r>
+            <a:endParaRPr lang="en-US" sz="1150" dirty="0"/>
+          </a:p>
+          <a:p>
+            <a:pPr indent="0" marL="0">
+              <a:buNone/>
+            </a:pPr>
+            <a:r>
+              <a:rPr lang="en-US" sz="1150" b="1" dirty="0">
+                <a:solidFill>
+                  <a:srgbClr val="FFFFFF"/>
+                </a:solidFill>
+                <a:latin typeface="Calibri" pitchFamily="34" charset="0"/>
+                <a:ea typeface="Calibri" pitchFamily="34" charset="-122"/>
+                <a:cs typeface="Calibri" pitchFamily="34" charset="-120"/>
+              </a:rPr>
+              <a:t>= USD 250M</a:t>
+            </a:r>
+            <a:endParaRPr lang="en-US" sz="1150" dirty="0"/>
+          </a:p>
+        </p:txBody>
+      </p:sp>
+      <p:sp>
+        <p:nvSpPr>
+          <p:cNvPr id="7" name="Text 5"/>
+          <p:cNvSpPr txBox="1"/>
+          <p:nvPr/>
+        </p:nvSpPr>
+        <p:spPr>
+          <a:xfrm>
+            <a:off x="640080" y="3337560"/>
+            <a:ext cx="2377440" cy="1188720"/>
+          </a:xfrm>
+          <a:prstGeom prst="rect">
+            <a:avLst/>
+          </a:prstGeom>
+          <a:noFill/>
+          <a:ln/>
+        </p:spPr>
+        <p:txBody>
+          <a:bodyPr wrap="square" lIns="0" tIns="0" rIns="0" bIns="0" rtlCol="0" anchor="t"/>
+          <a:lstStyle/>
+          <a:p>
+            <a:pPr indent="0" marL="0">
+              <a:buNone/>
+            </a:pPr>
+            <a:r>
+              <a:rPr lang="en-US" sz="1050" dirty="0">
+                <a:solidFill>
+                  <a:srgbClr val="E9E2F6"/>
+                </a:solidFill>
+                <a:latin typeface="Calibri" pitchFamily="34" charset="0"/>
+                <a:ea typeface="Calibri" pitchFamily="34" charset="-122"/>
+                <a:cs typeface="Calibri" pitchFamily="34" charset="-120"/>
+              </a:rPr>
+              <a:t>Proposed KRW 135bn ≈ USD 97M uses 39% of the budget. Max loss ≈ USD 9.7M = 10 bp of AUM, a third of the USD 30M lost with the previous manager.</a:t>
+            </a:r>
+            <a:endParaRPr lang="en-US" sz="1050" dirty="0"/>
+          </a:p>
+        </p:txBody>
+      </p:sp>
+      <p:sp>
+        <p:nvSpPr>
+          <p:cNvPr id="8" name="Text 6"/>
+          <p:cNvSpPr txBox="1"/>
+          <p:nvPr/>
+        </p:nvSpPr>
+        <p:spPr>
+          <a:xfrm>
+            <a:off x="3429000" y="1280160"/>
+            <a:ext cx="2514600" cy="274320"/>
+          </a:xfrm>
+          <a:prstGeom prst="rect">
+            <a:avLst/>
+          </a:prstGeom>
+          <a:noFill/>
+          <a:ln/>
+        </p:spPr>
+        <p:txBody>
+          <a:bodyPr wrap="square" lIns="0" tIns="0" rIns="0" bIns="0" rtlCol="0" anchor="ctr"/>
+          <a:lstStyle/>
+          <a:p>
+            <a:pPr indent="0" marL="0">
+              <a:buNone/>
+            </a:pPr>
+            <a:r>
+              <a:rPr lang="en-US" sz="1200" b="1" dirty="0">
+                <a:solidFill>
+                  <a:srgbClr val="2A1650"/>
+                </a:solidFill>
+                <a:latin typeface="Cambria" pitchFamily="34" charset="0"/>
+                <a:ea typeface="Cambria" pitchFamily="34" charset="-122"/>
+                <a:cs typeface="Cambria" pitchFamily="34" charset="-120"/>
+              </a:rPr>
+              <a:t>VaR and Greeks (% notional)</a:t>
+            </a:r>
+            <a:endParaRPr lang="en-US" sz="1200" dirty="0"/>
           </a:p>
         </p:txBody>
       </p:sp>
@@ -4094,19 +4362,18 @@
           </p:nvPr>
         </p:nvGraphicFramePr>
         <p:xfrm>
-          <a:off x="457200" y="1280160"/>
-          <a:ext cx="8229600" cy="914400"/>
+          <a:off x="3429000" y="1600200"/>
+          <a:ext cx="2423160" cy="914400"/>
         </p:xfrm>
         <a:graphic>
           <a:graphicData uri="http://schemas.openxmlformats.org/drawingml/2006/table">
             <a:tbl>
               <a:tblPr/>
               <a:tblGrid>
-                <a:gridCol w="1737360"/>
-                <a:gridCol w="3520440"/>
-                <a:gridCol w="2971800"/>
+                <a:gridCol w="1783080"/>
+                <a:gridCol w="640080"/>
               </a:tblGrid>
-              <a:tr h="438912">
+              <a:tr h="329184">
                 <a:tc>
                   <a:txBody>
                     <a:bodyPr/>
@@ -4116,213 +4383,7 @@
                         <a:buNone/>
                       </a:pPr>
                       <a:r>
-                        <a:rPr lang="en-US" sz="1050" b="1" dirty="0">
-                          <a:solidFill>
-                            <a:srgbClr val="FFFFFF"/>
-                          </a:solidFill>
-                          <a:latin typeface="Calibri" pitchFamily="34" charset="0"/>
-                          <a:ea typeface="Calibri" pitchFamily="34" charset="-122"/>
-                          <a:cs typeface="Calibri" pitchFamily="34" charset="-120"/>
-                        </a:rPr>
-                        <a:t>Risk</a:t>
-                      </a:r>
-                      <a:endParaRPr lang="en-US" sz="1050" dirty="0">
-                        <a:latin typeface="Calibri" charset="0"/>
-                        <a:ea typeface="Calibri" charset="0"/>
-                        <a:cs typeface="Calibri" charset="0"/>
-                      </a:endParaRPr>
-                    </a:p>
-                  </a:txBody>
-                  <a:tcPr marL="91440" marR="91440" marT="45720" marB="45720" anchor="ctr">
-                    <a:lnL w="6350" cap="flat" cmpd="sng" algn="ctr">
-                      <a:solidFill>
-                        <a:srgbClr val="D9D2E9"/>
-                      </a:solidFill>
-                      <a:prstDash val="solid"/>
-                      <a:round/>
-                      <a:headEnd type="none" w="med" len="med"/>
-                      <a:tailEnd type="none" w="med" len="med"/>
-                    </a:lnL>
-                    <a:lnR w="6350" cap="flat" cmpd="sng" algn="ctr">
-                      <a:solidFill>
-                        <a:srgbClr val="D9D2E9"/>
-                      </a:solidFill>
-                      <a:prstDash val="solid"/>
-                      <a:round/>
-                      <a:headEnd type="none" w="med" len="med"/>
-                      <a:tailEnd type="none" w="med" len="med"/>
-                    </a:lnR>
-                    <a:lnT w="6350" cap="flat" cmpd="sng" algn="ctr">
-                      <a:solidFill>
-                        <a:srgbClr val="D9D2E9"/>
-                      </a:solidFill>
-                      <a:prstDash val="solid"/>
-                      <a:round/>
-                      <a:headEnd type="none" w="med" len="med"/>
-                      <a:tailEnd type="none" w="med" len="med"/>
-                    </a:lnT>
-                    <a:lnB w="6350" cap="flat" cmpd="sng" algn="ctr">
-                      <a:solidFill>
-                        <a:srgbClr val="D9D2E9"/>
-                      </a:solidFill>
-                      <a:prstDash val="solid"/>
-                      <a:round/>
-                      <a:headEnd type="none" w="med" len="med"/>
-                      <a:tailEnd type="none" w="med" len="med"/>
-                    </a:lnB>
-                    <a:solidFill>
-                      <a:srgbClr val="2A1650"/>
-                    </a:solidFill>
-                  </a:tcPr>
-                </a:tc>
-                <a:tc>
-                  <a:txBody>
-                    <a:bodyPr/>
-                    <a:lstStyle/>
-                    <a:p>
-                      <a:pPr indent="0" marL="0">
-                        <a:buNone/>
-                      </a:pPr>
-                      <a:r>
-                        <a:rPr lang="en-US" sz="1050" b="1" dirty="0">
-                          <a:solidFill>
-                            <a:srgbClr val="FFFFFF"/>
-                          </a:solidFill>
-                          <a:latin typeface="Calibri" pitchFamily="34" charset="0"/>
-                          <a:ea typeface="Calibri" pitchFamily="34" charset="-122"/>
-                          <a:cs typeface="Calibri" pitchFamily="34" charset="-120"/>
-                        </a:rPr>
-                        <a:t>What could happen</a:t>
-                      </a:r>
-                      <a:endParaRPr lang="en-US" sz="1050" dirty="0">
-                        <a:latin typeface="Calibri" charset="0"/>
-                        <a:ea typeface="Calibri" charset="0"/>
-                        <a:cs typeface="Calibri" charset="0"/>
-                      </a:endParaRPr>
-                    </a:p>
-                  </a:txBody>
-                  <a:tcPr marL="91440" marR="91440" marT="45720" marB="45720" anchor="ctr">
-                    <a:lnL w="6350" cap="flat" cmpd="sng" algn="ctr">
-                      <a:solidFill>
-                        <a:srgbClr val="D9D2E9"/>
-                      </a:solidFill>
-                      <a:prstDash val="solid"/>
-                      <a:round/>
-                      <a:headEnd type="none" w="med" len="med"/>
-                      <a:tailEnd type="none" w="med" len="med"/>
-                    </a:lnL>
-                    <a:lnR w="6350" cap="flat" cmpd="sng" algn="ctr">
-                      <a:solidFill>
-                        <a:srgbClr val="D9D2E9"/>
-                      </a:solidFill>
-                      <a:prstDash val="solid"/>
-                      <a:round/>
-                      <a:headEnd type="none" w="med" len="med"/>
-                      <a:tailEnd type="none" w="med" len="med"/>
-                    </a:lnR>
-                    <a:lnT w="6350" cap="flat" cmpd="sng" algn="ctr">
-                      <a:solidFill>
-                        <a:srgbClr val="D9D2E9"/>
-                      </a:solidFill>
-                      <a:prstDash val="solid"/>
-                      <a:round/>
-                      <a:headEnd type="none" w="med" len="med"/>
-                      <a:tailEnd type="none" w="med" len="med"/>
-                    </a:lnT>
-                    <a:lnB w="6350" cap="flat" cmpd="sng" algn="ctr">
-                      <a:solidFill>
-                        <a:srgbClr val="D9D2E9"/>
-                      </a:solidFill>
-                      <a:prstDash val="solid"/>
-                      <a:round/>
-                      <a:headEnd type="none" w="med" len="med"/>
-                      <a:tailEnd type="none" w="med" len="med"/>
-                    </a:lnB>
-                    <a:solidFill>
-                      <a:srgbClr val="2A1650"/>
-                    </a:solidFill>
-                  </a:tcPr>
-                </a:tc>
-                <a:tc>
-                  <a:txBody>
-                    <a:bodyPr/>
-                    <a:lstStyle/>
-                    <a:p>
-                      <a:pPr indent="0" marL="0">
-                        <a:buNone/>
-                      </a:pPr>
-                      <a:r>
-                        <a:rPr lang="en-US" sz="1050" b="1" dirty="0">
-                          <a:solidFill>
-                            <a:srgbClr val="FFFFFF"/>
-                          </a:solidFill>
-                          <a:latin typeface="Calibri" pitchFamily="34" charset="0"/>
-                          <a:ea typeface="Calibri" pitchFamily="34" charset="-122"/>
-                          <a:cs typeface="Calibri" pitchFamily="34" charset="-120"/>
-                        </a:rPr>
-                        <a:t>Mitigant</a:t>
-                      </a:r>
-                      <a:endParaRPr lang="en-US" sz="1050" dirty="0">
-                        <a:latin typeface="Calibri" charset="0"/>
-                        <a:ea typeface="Calibri" charset="0"/>
-                        <a:cs typeface="Calibri" charset="0"/>
-                      </a:endParaRPr>
-                    </a:p>
-                  </a:txBody>
-                  <a:tcPr marL="91440" marR="91440" marT="45720" marB="45720" anchor="ctr">
-                    <a:lnL w="6350" cap="flat" cmpd="sng" algn="ctr">
-                      <a:solidFill>
-                        <a:srgbClr val="D9D2E9"/>
-                      </a:solidFill>
-                      <a:prstDash val="solid"/>
-                      <a:round/>
-                      <a:headEnd type="none" w="med" len="med"/>
-                      <a:tailEnd type="none" w="med" len="med"/>
-                    </a:lnL>
-                    <a:lnR w="6350" cap="flat" cmpd="sng" algn="ctr">
-                      <a:solidFill>
-                        <a:srgbClr val="D9D2E9"/>
-                      </a:solidFill>
-                      <a:prstDash val="solid"/>
-                      <a:round/>
-                      <a:headEnd type="none" w="med" len="med"/>
-                      <a:tailEnd type="none" w="med" len="med"/>
-                    </a:lnR>
-                    <a:lnT w="6350" cap="flat" cmpd="sng" algn="ctr">
-                      <a:solidFill>
-                        <a:srgbClr val="D9D2E9"/>
-                      </a:solidFill>
-                      <a:prstDash val="solid"/>
-                      <a:round/>
-                      <a:headEnd type="none" w="med" len="med"/>
-                      <a:tailEnd type="none" w="med" len="med"/>
-                    </a:lnT>
-                    <a:lnB w="6350" cap="flat" cmpd="sng" algn="ctr">
-                      <a:solidFill>
-                        <a:srgbClr val="D9D2E9"/>
-                      </a:solidFill>
-                      <a:prstDash val="solid"/>
-                      <a:round/>
-                      <a:headEnd type="none" w="med" len="med"/>
-                      <a:tailEnd type="none" w="med" len="med"/>
-                    </a:lnB>
-                    <a:solidFill>
-                      <a:srgbClr val="2A1650"/>
-                    </a:solidFill>
-                  </a:tcPr>
-                </a:tc>
-              </a:tr>
-              <a:tr h="438912">
-                <a:tc>
-                  <a:txBody>
-                    <a:bodyPr/>
-                    <a:lstStyle/>
-                    <a:p>
-                      <a:pPr indent="0" marL="0">
-                        <a:buNone/>
-                      </a:pPr>
-                      <a:r>
-                        <a:rPr lang="en-US" sz="1050" b="1" dirty="0">
+                        <a:rPr lang="en-US" sz="950" dirty="0">
                           <a:solidFill>
                             <a:srgbClr val="1F1B2D"/>
                           </a:solidFill>
@@ -4330,9 +4391,9 @@
                           <a:ea typeface="Calibri" pitchFamily="34" charset="-122"/>
                           <a:cs typeface="Calibri" pitchFamily="34" charset="-120"/>
                         </a:rPr>
-                        <a:t>Oil spike, no rebound</a:t>
+                        <a:t>Fair value at issue</a:t>
                       </a:r>
-                      <a:endParaRPr lang="en-US" sz="1050" dirty="0">
+                      <a:endParaRPr lang="en-US" sz="950" dirty="0">
                         <a:latin typeface="Calibri" charset="0"/>
                         <a:ea typeface="Calibri" charset="0"/>
                         <a:cs typeface="Calibri" charset="0"/>
@@ -4386,11 +4447,81 @@
                     <a:bodyPr/>
                     <a:lstStyle/>
                     <a:p>
+                      <a:pPr algn="r" indent="0" marL="0">
+                        <a:buNone/>
+                      </a:pPr>
+                      <a:r>
+                        <a:rPr lang="en-US" sz="950" b="1" dirty="0">
+                          <a:solidFill>
+                            <a:srgbClr val="4B2E83"/>
+                          </a:solidFill>
+                          <a:latin typeface="Calibri" pitchFamily="34" charset="0"/>
+                          <a:ea typeface="Calibri" pitchFamily="34" charset="-122"/>
+                          <a:cs typeface="Calibri" pitchFamily="34" charset="-120"/>
+                        </a:rPr>
+                        <a:t>98.1%</a:t>
+                      </a:r>
+                      <a:endParaRPr lang="en-US" sz="950" dirty="0">
+                        <a:latin typeface="Calibri" charset="0"/>
+                        <a:ea typeface="Calibri" charset="0"/>
+                        <a:cs typeface="Calibri" charset="0"/>
+                      </a:endParaRPr>
+                    </a:p>
+                  </a:txBody>
+                  <a:tcPr marL="91440" marR="91440" marT="45720" marB="45720" anchor="ctr">
+                    <a:lnL w="6350" cap="flat" cmpd="sng" algn="ctr">
+                      <a:solidFill>
+                        <a:srgbClr val="D9D2E9"/>
+                      </a:solidFill>
+                      <a:prstDash val="solid"/>
+                      <a:round/>
+                      <a:headEnd type="none" w="med" len="med"/>
+                      <a:tailEnd type="none" w="med" len="med"/>
+                    </a:lnL>
+                    <a:lnR w="6350" cap="flat" cmpd="sng" algn="ctr">
+                      <a:solidFill>
+                        <a:srgbClr val="D9D2E9"/>
+                      </a:solidFill>
+                      <a:prstDash val="solid"/>
+                      <a:round/>
+                      <a:headEnd type="none" w="med" len="med"/>
+                      <a:tailEnd type="none" w="med" len="med"/>
+                    </a:lnR>
+                    <a:lnT w="6350" cap="flat" cmpd="sng" algn="ctr">
+                      <a:solidFill>
+                        <a:srgbClr val="D9D2E9"/>
+                      </a:solidFill>
+                      <a:prstDash val="solid"/>
+                      <a:round/>
+                      <a:headEnd type="none" w="med" len="med"/>
+                      <a:tailEnd type="none" w="med" len="med"/>
+                    </a:lnT>
+                    <a:lnB w="6350" cap="flat" cmpd="sng" algn="ctr">
+                      <a:solidFill>
+                        <a:srgbClr val="D9D2E9"/>
+                      </a:solidFill>
+                      <a:prstDash val="solid"/>
+                      <a:round/>
+                      <a:headEnd type="none" w="med" len="med"/>
+                      <a:tailEnd type="none" w="med" len="med"/>
+                    </a:lnB>
+                    <a:solidFill>
+                      <a:srgbClr val="EEE8F7"/>
+                    </a:solidFill>
+                  </a:tcPr>
+                </a:tc>
+              </a:tr>
+              <a:tr h="329184">
+                <a:tc>
+                  <a:txBody>
+                    <a:bodyPr/>
+                    <a:lstStyle/>
+                    <a:p>
                       <a:pPr indent="0" marL="0">
                         <a:buNone/>
                       </a:pPr>
                       <a:r>
-                        <a:rPr lang="en-US" sz="1050" dirty="0">
+                        <a:rPr lang="en-US" sz="950" dirty="0">
                           <a:solidFill>
                             <a:srgbClr val="1F1B2D"/>
                           </a:solidFill>
@@ -4398,9 +4529,147 @@
                           <a:ea typeface="Calibri" pitchFamily="34" charset="-122"/>
                           <a:cs typeface="Calibri" pitchFamily="34" charset="-120"/>
                         </a:rPr>
-                        <a:t>2022-type path: oil up, KOSPI keeps falling; A expires worthless</a:t>
+                        <a:t>10-day 99% VaR (delta-normal)</a:t>
                       </a:r>
-                      <a:endParaRPr lang="en-US" sz="1050" dirty="0">
+                      <a:endParaRPr lang="en-US" sz="950" dirty="0">
+                        <a:latin typeface="Calibri" charset="0"/>
+                        <a:ea typeface="Calibri" charset="0"/>
+                        <a:cs typeface="Calibri" charset="0"/>
+                      </a:endParaRPr>
+                    </a:p>
+                  </a:txBody>
+                  <a:tcPr marL="91440" marR="91440" marT="45720" marB="45720" anchor="ctr">
+                    <a:lnL w="6350" cap="flat" cmpd="sng" algn="ctr">
+                      <a:solidFill>
+                        <a:srgbClr val="D9D2E9"/>
+                      </a:solidFill>
+                      <a:prstDash val="solid"/>
+                      <a:round/>
+                      <a:headEnd type="none" w="med" len="med"/>
+                      <a:tailEnd type="none" w="med" len="med"/>
+                    </a:lnL>
+                    <a:lnR w="6350" cap="flat" cmpd="sng" algn="ctr">
+                      <a:solidFill>
+                        <a:srgbClr val="D9D2E9"/>
+                      </a:solidFill>
+                      <a:prstDash val="solid"/>
+                      <a:round/>
+                      <a:headEnd type="none" w="med" len="med"/>
+                      <a:tailEnd type="none" w="med" len="med"/>
+                    </a:lnR>
+                    <a:lnT w="6350" cap="flat" cmpd="sng" algn="ctr">
+                      <a:solidFill>
+                        <a:srgbClr val="D9D2E9"/>
+                      </a:solidFill>
+                      <a:prstDash val="solid"/>
+                      <a:round/>
+                      <a:headEnd type="none" w="med" len="med"/>
+                      <a:tailEnd type="none" w="med" len="med"/>
+                    </a:lnT>
+                    <a:lnB w="6350" cap="flat" cmpd="sng" algn="ctr">
+                      <a:solidFill>
+                        <a:srgbClr val="D9D2E9"/>
+                      </a:solidFill>
+                      <a:prstDash val="solid"/>
+                      <a:round/>
+                      <a:headEnd type="none" w="med" len="med"/>
+                      <a:tailEnd type="none" w="med" len="med"/>
+                    </a:lnB>
+                    <a:solidFill>
+                      <a:srgbClr val="FFFFFF"/>
+                    </a:solidFill>
+                  </a:tcPr>
+                </a:tc>
+                <a:tc>
+                  <a:txBody>
+                    <a:bodyPr/>
+                    <a:lstStyle/>
+                    <a:p>
+                      <a:pPr algn="r" indent="0" marL="0">
+                        <a:buNone/>
+                      </a:pPr>
+                      <a:r>
+                        <a:rPr lang="en-US" sz="950" b="1" dirty="0">
+                          <a:solidFill>
+                            <a:srgbClr val="4B2E83"/>
+                          </a:solidFill>
+                          <a:latin typeface="Calibri" pitchFamily="34" charset="0"/>
+                          <a:ea typeface="Calibri" pitchFamily="34" charset="-122"/>
+                          <a:cs typeface="Calibri" pitchFamily="34" charset="-120"/>
+                        </a:rPr>
+                        <a:t>5.6%</a:t>
+                      </a:r>
+                      <a:endParaRPr lang="en-US" sz="950" dirty="0">
+                        <a:latin typeface="Calibri" charset="0"/>
+                        <a:ea typeface="Calibri" charset="0"/>
+                        <a:cs typeface="Calibri" charset="0"/>
+                      </a:endParaRPr>
+                    </a:p>
+                  </a:txBody>
+                  <a:tcPr marL="91440" marR="91440" marT="45720" marB="45720" anchor="ctr">
+                    <a:lnL w="6350" cap="flat" cmpd="sng" algn="ctr">
+                      <a:solidFill>
+                        <a:srgbClr val="D9D2E9"/>
+                      </a:solidFill>
+                      <a:prstDash val="solid"/>
+                      <a:round/>
+                      <a:headEnd type="none" w="med" len="med"/>
+                      <a:tailEnd type="none" w="med" len="med"/>
+                    </a:lnL>
+                    <a:lnR w="6350" cap="flat" cmpd="sng" algn="ctr">
+                      <a:solidFill>
+                        <a:srgbClr val="D9D2E9"/>
+                      </a:solidFill>
+                      <a:prstDash val="solid"/>
+                      <a:round/>
+                      <a:headEnd type="none" w="med" len="med"/>
+                      <a:tailEnd type="none" w="med" len="med"/>
+                    </a:lnR>
+                    <a:lnT w="6350" cap="flat" cmpd="sng" algn="ctr">
+                      <a:solidFill>
+                        <a:srgbClr val="D9D2E9"/>
+                      </a:solidFill>
+                      <a:prstDash val="solid"/>
+                      <a:round/>
+                      <a:headEnd type="none" w="med" len="med"/>
+                      <a:tailEnd type="none" w="med" len="med"/>
+                    </a:lnT>
+                    <a:lnB w="6350" cap="flat" cmpd="sng" algn="ctr">
+                      <a:solidFill>
+                        <a:srgbClr val="D9D2E9"/>
+                      </a:solidFill>
+                      <a:prstDash val="solid"/>
+                      <a:round/>
+                      <a:headEnd type="none" w="med" len="med"/>
+                      <a:tailEnd type="none" w="med" len="med"/>
+                    </a:lnB>
+                    <a:solidFill>
+                      <a:srgbClr val="FFFFFF"/>
+                    </a:solidFill>
+                  </a:tcPr>
+                </a:tc>
+              </a:tr>
+              <a:tr h="329184">
+                <a:tc>
+                  <a:txBody>
+                    <a:bodyPr/>
+                    <a:lstStyle/>
+                    <a:p>
+                      <a:pPr indent="0" marL="0">
+                        <a:buNone/>
+                      </a:pPr>
+                      <a:r>
+                        <a:rPr lang="en-US" sz="950" dirty="0">
+                          <a:solidFill>
+                            <a:srgbClr val="1F1B2D"/>
+                          </a:solidFill>
+                          <a:latin typeface="Calibri" pitchFamily="34" charset="0"/>
+                          <a:ea typeface="Calibri" pitchFamily="34" charset="-122"/>
+                          <a:cs typeface="Calibri" pitchFamily="34" charset="-120"/>
+                        </a:rPr>
+                        <a:t>Expected shortfall 99%</a:t>
+                      </a:r>
+                      <a:endParaRPr lang="en-US" sz="950" dirty="0">
                         <a:latin typeface="Calibri" charset="0"/>
                         <a:ea typeface="Calibri" charset="0"/>
                         <a:cs typeface="Calibri" charset="0"/>
@@ -4454,21 +4723,21 @@
                     <a:bodyPr/>
                     <a:lstStyle/>
                     <a:p>
-                      <a:pPr indent="0" marL="0">
+                      <a:pPr algn="r" indent="0" marL="0">
                         <a:buNone/>
                       </a:pPr>
                       <a:r>
-                        <a:rPr lang="en-US" sz="1050" dirty="0">
+                        <a:rPr lang="en-US" sz="950" b="1" dirty="0">
                           <a:solidFill>
-                            <a:srgbClr val="1F1B2D"/>
+                            <a:srgbClr val="4B2E83"/>
                           </a:solidFill>
                           <a:latin typeface="Calibri" pitchFamily="34" charset="0"/>
                           <a:ea typeface="Calibri" pitchFamily="34" charset="-122"/>
                           <a:cs typeface="Calibri" pitchFamily="34" charset="-120"/>
                         </a:rPr>
-                        <a:t>Max loss capped at 10%; test delayed-strike variant</a:t>
+                        <a:t>6.4%</a:t>
                       </a:r>
-                      <a:endParaRPr lang="en-US" sz="1050" dirty="0">
+                      <a:endParaRPr lang="en-US" sz="950" dirty="0">
                         <a:latin typeface="Calibri" charset="0"/>
                         <a:ea typeface="Calibri" charset="0"/>
                         <a:cs typeface="Calibri" charset="0"/>
@@ -4518,7 +4787,7 @@
                   </a:tcPr>
                 </a:tc>
               </a:tr>
-              <a:tr h="438912">
+              <a:tr h="329184">
                 <a:tc>
                   <a:txBody>
                     <a:bodyPr/>
@@ -4528,7 +4797,7 @@
                         <a:buNone/>
                       </a:pPr>
                       <a:r>
-                        <a:rPr lang="en-US" sz="1050" b="1" dirty="0">
+                        <a:rPr lang="en-US" sz="950" dirty="0">
                           <a:solidFill>
                             <a:srgbClr val="1F1B2D"/>
                           </a:solidFill>
@@ -4536,9 +4805,9 @@
                           <a:ea typeface="Calibri" pitchFamily="34" charset="-122"/>
                           <a:cs typeface="Calibri" pitchFamily="34" charset="-120"/>
                         </a:rPr>
-                        <a:t>Correlation</a:t>
+                        <a:t>Delta Brent / +1%</a:t>
                       </a:r>
-                      <a:endParaRPr lang="en-US" sz="1050" dirty="0">
+                      <a:endParaRPr lang="en-US" sz="950" dirty="0">
                         <a:latin typeface="Calibri" charset="0"/>
                         <a:ea typeface="Calibri" charset="0"/>
                         <a:cs typeface="Calibri" charset="0"/>
@@ -4592,11 +4861,81 @@
                     <a:bodyPr/>
                     <a:lstStyle/>
                     <a:p>
+                      <a:pPr algn="r" indent="0" marL="0">
+                        <a:buNone/>
+                      </a:pPr>
+                      <a:r>
+                        <a:rPr lang="en-US" sz="950" b="1" dirty="0">
+                          <a:solidFill>
+                            <a:srgbClr val="4B2E83"/>
+                          </a:solidFill>
+                          <a:latin typeface="Calibri" pitchFamily="34" charset="0"/>
+                          <a:ea typeface="Calibri" pitchFamily="34" charset="-122"/>
+                          <a:cs typeface="Calibri" pitchFamily="34" charset="-120"/>
+                        </a:rPr>
+                        <a:t>+0.33</a:t>
+                      </a:r>
+                      <a:endParaRPr lang="en-US" sz="950" dirty="0">
+                        <a:latin typeface="Calibri" charset="0"/>
+                        <a:ea typeface="Calibri" charset="0"/>
+                        <a:cs typeface="Calibri" charset="0"/>
+                      </a:endParaRPr>
+                    </a:p>
+                  </a:txBody>
+                  <a:tcPr marL="91440" marR="91440" marT="45720" marB="45720" anchor="ctr">
+                    <a:lnL w="6350" cap="flat" cmpd="sng" algn="ctr">
+                      <a:solidFill>
+                        <a:srgbClr val="D9D2E9"/>
+                      </a:solidFill>
+                      <a:prstDash val="solid"/>
+                      <a:round/>
+                      <a:headEnd type="none" w="med" len="med"/>
+                      <a:tailEnd type="none" w="med" len="med"/>
+                    </a:lnL>
+                    <a:lnR w="6350" cap="flat" cmpd="sng" algn="ctr">
+                      <a:solidFill>
+                        <a:srgbClr val="D9D2E9"/>
+                      </a:solidFill>
+                      <a:prstDash val="solid"/>
+                      <a:round/>
+                      <a:headEnd type="none" w="med" len="med"/>
+                      <a:tailEnd type="none" w="med" len="med"/>
+                    </a:lnR>
+                    <a:lnT w="6350" cap="flat" cmpd="sng" algn="ctr">
+                      <a:solidFill>
+                        <a:srgbClr val="D9D2E9"/>
+                      </a:solidFill>
+                      <a:prstDash val="solid"/>
+                      <a:round/>
+                      <a:headEnd type="none" w="med" len="med"/>
+                      <a:tailEnd type="none" w="med" len="med"/>
+                    </a:lnT>
+                    <a:lnB w="6350" cap="flat" cmpd="sng" algn="ctr">
+                      <a:solidFill>
+                        <a:srgbClr val="D9D2E9"/>
+                      </a:solidFill>
+                      <a:prstDash val="solid"/>
+                      <a:round/>
+                      <a:headEnd type="none" w="med" len="med"/>
+                      <a:tailEnd type="none" w="med" len="med"/>
+                    </a:lnB>
+                    <a:solidFill>
+                      <a:srgbClr val="FFFFFF"/>
+                    </a:solidFill>
+                  </a:tcPr>
+                </a:tc>
+              </a:tr>
+              <a:tr h="329184">
+                <a:tc>
+                  <a:txBody>
+                    <a:bodyPr/>
+                    <a:lstStyle/>
+                    <a:p>
                       <a:pPr indent="0" marL="0">
                         <a:buNone/>
                       </a:pPr>
                       <a:r>
-                        <a:rPr lang="en-US" sz="1050" dirty="0">
+                        <a:rPr lang="en-US" sz="950" dirty="0">
                           <a:solidFill>
                             <a:srgbClr val="1F1B2D"/>
                           </a:solidFill>
@@ -4604,9 +4943,147 @@
                           <a:ea typeface="Calibri" pitchFamily="34" charset="-122"/>
                           <a:cs typeface="Calibri" pitchFamily="34" charset="-120"/>
                         </a:rPr>
-                        <a:t>Oil–KRW link strengthens; B's probability falls</a:t>
+                        <a:t>Delta KOSPI 200 / +1%</a:t>
                       </a:r>
-                      <a:endParaRPr lang="en-US" sz="1050" dirty="0">
+                      <a:endParaRPr lang="en-US" sz="950" dirty="0">
+                        <a:latin typeface="Calibri" charset="0"/>
+                        <a:ea typeface="Calibri" charset="0"/>
+                        <a:cs typeface="Calibri" charset="0"/>
+                      </a:endParaRPr>
+                    </a:p>
+                  </a:txBody>
+                  <a:tcPr marL="91440" marR="91440" marT="45720" marB="45720" anchor="ctr">
+                    <a:lnL w="6350" cap="flat" cmpd="sng" algn="ctr">
+                      <a:solidFill>
+                        <a:srgbClr val="D9D2E9"/>
+                      </a:solidFill>
+                      <a:prstDash val="solid"/>
+                      <a:round/>
+                      <a:headEnd type="none" w="med" len="med"/>
+                      <a:tailEnd type="none" w="med" len="med"/>
+                    </a:lnL>
+                    <a:lnR w="6350" cap="flat" cmpd="sng" algn="ctr">
+                      <a:solidFill>
+                        <a:srgbClr val="D9D2E9"/>
+                      </a:solidFill>
+                      <a:prstDash val="solid"/>
+                      <a:round/>
+                      <a:headEnd type="none" w="med" len="med"/>
+                      <a:tailEnd type="none" w="med" len="med"/>
+                    </a:lnR>
+                    <a:lnT w="6350" cap="flat" cmpd="sng" algn="ctr">
+                      <a:solidFill>
+                        <a:srgbClr val="D9D2E9"/>
+                      </a:solidFill>
+                      <a:prstDash val="solid"/>
+                      <a:round/>
+                      <a:headEnd type="none" w="med" len="med"/>
+                      <a:tailEnd type="none" w="med" len="med"/>
+                    </a:lnT>
+                    <a:lnB w="6350" cap="flat" cmpd="sng" algn="ctr">
+                      <a:solidFill>
+                        <a:srgbClr val="D9D2E9"/>
+                      </a:solidFill>
+                      <a:prstDash val="solid"/>
+                      <a:round/>
+                      <a:headEnd type="none" w="med" len="med"/>
+                      <a:tailEnd type="none" w="med" len="med"/>
+                    </a:lnB>
+                    <a:solidFill>
+                      <a:srgbClr val="EEE8F7"/>
+                    </a:solidFill>
+                  </a:tcPr>
+                </a:tc>
+                <a:tc>
+                  <a:txBody>
+                    <a:bodyPr/>
+                    <a:lstStyle/>
+                    <a:p>
+                      <a:pPr algn="r" indent="0" marL="0">
+                        <a:buNone/>
+                      </a:pPr>
+                      <a:r>
+                        <a:rPr lang="en-US" sz="950" b="1" dirty="0">
+                          <a:solidFill>
+                            <a:srgbClr val="4B2E83"/>
+                          </a:solidFill>
+                          <a:latin typeface="Calibri" pitchFamily="34" charset="0"/>
+                          <a:ea typeface="Calibri" pitchFamily="34" charset="-122"/>
+                          <a:cs typeface="Calibri" pitchFamily="34" charset="-120"/>
+                        </a:rPr>
+                        <a:t>+0.26</a:t>
+                      </a:r>
+                      <a:endParaRPr lang="en-US" sz="950" dirty="0">
+                        <a:latin typeface="Calibri" charset="0"/>
+                        <a:ea typeface="Calibri" charset="0"/>
+                        <a:cs typeface="Calibri" charset="0"/>
+                      </a:endParaRPr>
+                    </a:p>
+                  </a:txBody>
+                  <a:tcPr marL="91440" marR="91440" marT="45720" marB="45720" anchor="ctr">
+                    <a:lnL w="6350" cap="flat" cmpd="sng" algn="ctr">
+                      <a:solidFill>
+                        <a:srgbClr val="D9D2E9"/>
+                      </a:solidFill>
+                      <a:prstDash val="solid"/>
+                      <a:round/>
+                      <a:headEnd type="none" w="med" len="med"/>
+                      <a:tailEnd type="none" w="med" len="med"/>
+                    </a:lnL>
+                    <a:lnR w="6350" cap="flat" cmpd="sng" algn="ctr">
+                      <a:solidFill>
+                        <a:srgbClr val="D9D2E9"/>
+                      </a:solidFill>
+                      <a:prstDash val="solid"/>
+                      <a:round/>
+                      <a:headEnd type="none" w="med" len="med"/>
+                      <a:tailEnd type="none" w="med" len="med"/>
+                    </a:lnR>
+                    <a:lnT w="6350" cap="flat" cmpd="sng" algn="ctr">
+                      <a:solidFill>
+                        <a:srgbClr val="D9D2E9"/>
+                      </a:solidFill>
+                      <a:prstDash val="solid"/>
+                      <a:round/>
+                      <a:headEnd type="none" w="med" len="med"/>
+                      <a:tailEnd type="none" w="med" len="med"/>
+                    </a:lnT>
+                    <a:lnB w="6350" cap="flat" cmpd="sng" algn="ctr">
+                      <a:solidFill>
+                        <a:srgbClr val="D9D2E9"/>
+                      </a:solidFill>
+                      <a:prstDash val="solid"/>
+                      <a:round/>
+                      <a:headEnd type="none" w="med" len="med"/>
+                      <a:tailEnd type="none" w="med" len="med"/>
+                    </a:lnB>
+                    <a:solidFill>
+                      <a:srgbClr val="EEE8F7"/>
+                    </a:solidFill>
+                  </a:tcPr>
+                </a:tc>
+              </a:tr>
+              <a:tr h="329184">
+                <a:tc>
+                  <a:txBody>
+                    <a:bodyPr/>
+                    <a:lstStyle/>
+                    <a:p>
+                      <a:pPr indent="0" marL="0">
+                        <a:buNone/>
+                      </a:pPr>
+                      <a:r>
+                        <a:rPr lang="en-US" sz="950" dirty="0">
+                          <a:solidFill>
+                            <a:srgbClr val="1F1B2D"/>
+                          </a:solidFill>
+                          <a:latin typeface="Calibri" pitchFamily="34" charset="0"/>
+                          <a:ea typeface="Calibri" pitchFamily="34" charset="-122"/>
+                          <a:cs typeface="Calibri" pitchFamily="34" charset="-120"/>
+                        </a:rPr>
+                        <a:t>Delta USD/KRW / +1%</a:t>
+                      </a:r>
+                      <a:endParaRPr lang="en-US" sz="950" dirty="0">
                         <a:latin typeface="Calibri" charset="0"/>
                         <a:ea typeface="Calibri" charset="0"/>
                         <a:cs typeface="Calibri" charset="0"/>
@@ -4660,21 +5137,21 @@
                     <a:bodyPr/>
                     <a:lstStyle/>
                     <a:p>
-                      <a:pPr indent="0" marL="0">
+                      <a:pPr algn="r" indent="0" marL="0">
                         <a:buNone/>
                       </a:pPr>
                       <a:r>
-                        <a:rPr lang="en-US" sz="1050" dirty="0">
+                        <a:rPr lang="en-US" sz="950" b="1" dirty="0">
                           <a:solidFill>
-                            <a:srgbClr val="1F1B2D"/>
+                            <a:srgbClr val="4B2E83"/>
                           </a:solidFill>
                           <a:latin typeface="Calibri" pitchFamily="34" charset="0"/>
                           <a:ea typeface="Calibri" pitchFamily="34" charset="-122"/>
                           <a:cs typeface="Calibri" pitchFamily="34" charset="-120"/>
                         </a:rPr>
-                        <a:t>Size B at 3%; show correlation sensitivity</a:t>
+                        <a:t>−0.30</a:t>
                       </a:r>
-                      <a:endParaRPr lang="en-US" sz="1050" dirty="0">
+                      <a:endParaRPr lang="en-US" sz="950" dirty="0">
                         <a:latin typeface="Calibri" charset="0"/>
                         <a:ea typeface="Calibri" charset="0"/>
                         <a:cs typeface="Calibri" charset="0"/>
@@ -4724,7 +5201,7 @@
                   </a:tcPr>
                 </a:tc>
               </a:tr>
-              <a:tr h="438912">
+              <a:tr h="329184">
                 <a:tc>
                   <a:txBody>
                     <a:bodyPr/>
@@ -4734,7 +5211,7 @@
                         <a:buNone/>
                       </a:pPr>
                       <a:r>
-                        <a:rPr lang="en-US" sz="1050" b="1" dirty="0">
+                        <a:rPr lang="en-US" sz="950" dirty="0">
                           <a:solidFill>
                             <a:srgbClr val="1F1B2D"/>
                           </a:solidFill>
@@ -4742,9 +5219,9 @@
                           <a:ea typeface="Calibri" pitchFamily="34" charset="-122"/>
                           <a:cs typeface="Calibri" pitchFamily="34" charset="-120"/>
                         </a:rPr>
-                        <a:t>Vol surface / skew</a:t>
+                        <a:t>Vega KOSPI / +1 vol pt</a:t>
                       </a:r>
-                      <a:endParaRPr lang="en-US" sz="1050" dirty="0">
+                      <a:endParaRPr lang="en-US" sz="950" dirty="0">
                         <a:latin typeface="Calibri" charset="0"/>
                         <a:ea typeface="Calibri" charset="0"/>
                         <a:cs typeface="Calibri" charset="0"/>
@@ -4798,21 +5275,21 @@
                     <a:bodyPr/>
                     <a:lstStyle/>
                     <a:p>
-                      <a:pPr indent="0" marL="0">
+                      <a:pPr algn="r" indent="0" marL="0">
                         <a:buNone/>
                       </a:pPr>
                       <a:r>
-                        <a:rPr lang="en-US" sz="1050" dirty="0">
+                        <a:rPr lang="en-US" sz="950" b="1" dirty="0">
                           <a:solidFill>
-                            <a:srgbClr val="1F1B2D"/>
+                            <a:srgbClr val="4B2E83"/>
                           </a:solidFill>
                           <a:latin typeface="Calibri" pitchFamily="34" charset="0"/>
                           <a:ea typeface="Calibri" pitchFamily="34" charset="-122"/>
                           <a:cs typeface="Calibri" pitchFamily="34" charset="-120"/>
                         </a:rPr>
-                        <a:t>Barrier and spread values move with skew and term structure</a:t>
+                        <a:t>+0.36</a:t>
                       </a:r>
-                      <a:endParaRPr lang="en-US" sz="1050" dirty="0">
+                      <a:endParaRPr lang="en-US" sz="950" dirty="0">
                         <a:latin typeface="Calibri" charset="0"/>
                         <a:ea typeface="Calibri" charset="0"/>
                         <a:cs typeface="Calibri" charset="0"/>
@@ -4861,6 +5338,8 @@
                     </a:solidFill>
                   </a:tcPr>
                 </a:tc>
+              </a:tr>
+              <a:tr h="329184">
                 <a:tc>
                   <a:txBody>
                     <a:bodyPr/>
@@ -4870,7 +5349,7 @@
                         <a:buNone/>
                       </a:pPr>
                       <a:r>
-                        <a:rPr lang="en-US" sz="1050" dirty="0">
+                        <a:rPr lang="en-US" sz="950" dirty="0">
                           <a:solidFill>
                             <a:srgbClr val="1F1B2D"/>
                           </a:solidFill>
@@ -4878,79 +5357,9 @@
                           <a:ea typeface="Calibri" pitchFamily="34" charset="-122"/>
                           <a:cs typeface="Calibri" pitchFamily="34" charset="-120"/>
                         </a:rPr>
-                        <a:t>Skew-aware pricing; Greeks table per engine</a:t>
+                        <a:t>Worst MTM before maturity</a:t>
                       </a:r>
-                      <a:endParaRPr lang="en-US" sz="1050" dirty="0">
-                        <a:latin typeface="Calibri" charset="0"/>
-                        <a:ea typeface="Calibri" charset="0"/>
-                        <a:cs typeface="Calibri" charset="0"/>
-                      </a:endParaRPr>
-                    </a:p>
-                  </a:txBody>
-                  <a:tcPr marL="91440" marR="91440" marT="45720" marB="45720" anchor="ctr">
-                    <a:lnL w="6350" cap="flat" cmpd="sng" algn="ctr">
-                      <a:solidFill>
-                        <a:srgbClr val="D9D2E9"/>
-                      </a:solidFill>
-                      <a:prstDash val="solid"/>
-                      <a:round/>
-                      <a:headEnd type="none" w="med" len="med"/>
-                      <a:tailEnd type="none" w="med" len="med"/>
-                    </a:lnL>
-                    <a:lnR w="6350" cap="flat" cmpd="sng" algn="ctr">
-                      <a:solidFill>
-                        <a:srgbClr val="D9D2E9"/>
-                      </a:solidFill>
-                      <a:prstDash val="solid"/>
-                      <a:round/>
-                      <a:headEnd type="none" w="med" len="med"/>
-                      <a:tailEnd type="none" w="med" len="med"/>
-                    </a:lnR>
-                    <a:lnT w="6350" cap="flat" cmpd="sng" algn="ctr">
-                      <a:solidFill>
-                        <a:srgbClr val="D9D2E9"/>
-                      </a:solidFill>
-                      <a:prstDash val="solid"/>
-                      <a:round/>
-                      <a:headEnd type="none" w="med" len="med"/>
-                      <a:tailEnd type="none" w="med" len="med"/>
-                    </a:lnT>
-                    <a:lnB w="6350" cap="flat" cmpd="sng" algn="ctr">
-                      <a:solidFill>
-                        <a:srgbClr val="D9D2E9"/>
-                      </a:solidFill>
-                      <a:prstDash val="solid"/>
-                      <a:round/>
-                      <a:headEnd type="none" w="med" len="med"/>
-                      <a:tailEnd type="none" w="med" len="med"/>
-                    </a:lnB>
-                    <a:solidFill>
-                      <a:srgbClr val="EEE8F7"/>
-                    </a:solidFill>
-                  </a:tcPr>
-                </a:tc>
-              </a:tr>
-              <a:tr h="438912">
-                <a:tc>
-                  <a:txBody>
-                    <a:bodyPr/>
-                    <a:lstStyle/>
-                    <a:p>
-                      <a:pPr indent="0" marL="0">
-                        <a:buNone/>
-                      </a:pPr>
-                      <a:r>
-                        <a:rPr lang="en-US" sz="1050" b="1" dirty="0">
-                          <a:solidFill>
-                            <a:srgbClr val="1F1B2D"/>
-                          </a:solidFill>
-                          <a:latin typeface="Calibri" pitchFamily="34" charset="0"/>
-                          <a:ea typeface="Calibri" pitchFamily="34" charset="-122"/>
-                          <a:cs typeface="Calibri" pitchFamily="34" charset="-120"/>
-                        </a:rPr>
-                        <a:t>Natixis credit</a:t>
-                      </a:r>
-                      <a:endParaRPr lang="en-US" sz="1050" dirty="0">
+                      <a:endParaRPr lang="en-US" sz="950" dirty="0">
                         <a:latin typeface="Calibri" charset="0"/>
                         <a:ea typeface="Calibri" charset="0"/>
                         <a:cs typeface="Calibri" charset="0"/>
@@ -5004,501 +5413,21 @@
                     <a:bodyPr/>
                     <a:lstStyle/>
                     <a:p>
-                      <a:pPr indent="0" marL="0">
+                      <a:pPr algn="r" indent="0" marL="0">
                         <a:buNone/>
                       </a:pPr>
                       <a:r>
-                        <a:rPr lang="en-US" sz="1050" dirty="0">
+                        <a:rPr lang="en-US" sz="950" b="1" dirty="0">
                           <a:solidFill>
-                            <a:srgbClr val="1F1B2D"/>
+                            <a:srgbClr val="4B2E83"/>
                           </a:solidFill>
                           <a:latin typeface="Calibri" pitchFamily="34" charset="0"/>
                           <a:ea typeface="Calibri" pitchFamily="34" charset="-122"/>
                           <a:cs typeface="Calibri" pitchFamily="34" charset="-120"/>
                         </a:rPr>
-                        <a:t>Protection depends on the issuer</a:t>
+                        <a:t>~84%</a:t>
                       </a:r>
-                      <a:endParaRPr lang="en-US" sz="1050" dirty="0">
-                        <a:latin typeface="Calibri" charset="0"/>
-                        <a:ea typeface="Calibri" charset="0"/>
-                        <a:cs typeface="Calibri" charset="0"/>
-                      </a:endParaRPr>
-                    </a:p>
-                  </a:txBody>
-                  <a:tcPr marL="91440" marR="91440" marT="45720" marB="45720" anchor="ctr">
-                    <a:lnL w="6350" cap="flat" cmpd="sng" algn="ctr">
-                      <a:solidFill>
-                        <a:srgbClr val="D9D2E9"/>
-                      </a:solidFill>
-                      <a:prstDash val="solid"/>
-                      <a:round/>
-                      <a:headEnd type="none" w="med" len="med"/>
-                      <a:tailEnd type="none" w="med" len="med"/>
-                    </a:lnL>
-                    <a:lnR w="6350" cap="flat" cmpd="sng" algn="ctr">
-                      <a:solidFill>
-                        <a:srgbClr val="D9D2E9"/>
-                      </a:solidFill>
-                      <a:prstDash val="solid"/>
-                      <a:round/>
-                      <a:headEnd type="none" w="med" len="med"/>
-                      <a:tailEnd type="none" w="med" len="med"/>
-                    </a:lnR>
-                    <a:lnT w="6350" cap="flat" cmpd="sng" algn="ctr">
-                      <a:solidFill>
-                        <a:srgbClr val="D9D2E9"/>
-                      </a:solidFill>
-                      <a:prstDash val="solid"/>
-                      <a:round/>
-                      <a:headEnd type="none" w="med" len="med"/>
-                      <a:tailEnd type="none" w="med" len="med"/>
-                    </a:lnT>
-                    <a:lnB w="6350" cap="flat" cmpd="sng" algn="ctr">
-                      <a:solidFill>
-                        <a:srgbClr val="D9D2E9"/>
-                      </a:solidFill>
-                      <a:prstDash val="solid"/>
-                      <a:round/>
-                      <a:headEnd type="none" w="med" len="med"/>
-                      <a:tailEnd type="none" w="med" len="med"/>
-                    </a:lnB>
-                    <a:solidFill>
-                      <a:srgbClr val="FFFFFF"/>
-                    </a:solidFill>
-                  </a:tcPr>
-                </a:tc>
-                <a:tc>
-                  <a:txBody>
-                    <a:bodyPr/>
-                    <a:lstStyle/>
-                    <a:p>
-                      <a:pPr indent="0" marL="0">
-                        <a:buNone/>
-                      </a:pPr>
-                      <a:r>
-                        <a:rPr lang="en-US" sz="1050" dirty="0">
-                          <a:solidFill>
-                            <a:srgbClr val="1F1B2D"/>
-                          </a:solidFill>
-                          <a:latin typeface="Calibri" pitchFamily="34" charset="0"/>
-                          <a:ea typeface="Calibri" pitchFamily="34" charset="-122"/>
-                          <a:cs typeface="Calibri" pitchFamily="34" charset="-120"/>
-                        </a:rPr>
-                        <a:t>Disclose issuer rating and CDS</a:t>
-                      </a:r>
-                      <a:endParaRPr lang="en-US" sz="1050" dirty="0">
-                        <a:latin typeface="Calibri" charset="0"/>
-                        <a:ea typeface="Calibri" charset="0"/>
-                        <a:cs typeface="Calibri" charset="0"/>
-                      </a:endParaRPr>
-                    </a:p>
-                  </a:txBody>
-                  <a:tcPr marL="91440" marR="91440" marT="45720" marB="45720" anchor="ctr">
-                    <a:lnL w="6350" cap="flat" cmpd="sng" algn="ctr">
-                      <a:solidFill>
-                        <a:srgbClr val="D9D2E9"/>
-                      </a:solidFill>
-                      <a:prstDash val="solid"/>
-                      <a:round/>
-                      <a:headEnd type="none" w="med" len="med"/>
-                      <a:tailEnd type="none" w="med" len="med"/>
-                    </a:lnL>
-                    <a:lnR w="6350" cap="flat" cmpd="sng" algn="ctr">
-                      <a:solidFill>
-                        <a:srgbClr val="D9D2E9"/>
-                      </a:solidFill>
-                      <a:prstDash val="solid"/>
-                      <a:round/>
-                      <a:headEnd type="none" w="med" len="med"/>
-                      <a:tailEnd type="none" w="med" len="med"/>
-                    </a:lnR>
-                    <a:lnT w="6350" cap="flat" cmpd="sng" algn="ctr">
-                      <a:solidFill>
-                        <a:srgbClr val="D9D2E9"/>
-                      </a:solidFill>
-                      <a:prstDash val="solid"/>
-                      <a:round/>
-                      <a:headEnd type="none" w="med" len="med"/>
-                      <a:tailEnd type="none" w="med" len="med"/>
-                    </a:lnT>
-                    <a:lnB w="6350" cap="flat" cmpd="sng" algn="ctr">
-                      <a:solidFill>
-                        <a:srgbClr val="D9D2E9"/>
-                      </a:solidFill>
-                      <a:prstDash val="solid"/>
-                      <a:round/>
-                      <a:headEnd type="none" w="med" len="med"/>
-                      <a:tailEnd type="none" w="med" len="med"/>
-                    </a:lnB>
-                    <a:solidFill>
-                      <a:srgbClr val="FFFFFF"/>
-                    </a:solidFill>
-                  </a:tcPr>
-                </a:tc>
-              </a:tr>
-              <a:tr h="438912">
-                <a:tc>
-                  <a:txBody>
-                    <a:bodyPr/>
-                    <a:lstStyle/>
-                    <a:p>
-                      <a:pPr indent="0" marL="0">
-                        <a:buNone/>
-                      </a:pPr>
-                      <a:r>
-                        <a:rPr lang="en-US" sz="1050" b="1" dirty="0">
-                          <a:solidFill>
-                            <a:srgbClr val="1F1B2D"/>
-                          </a:solidFill>
-                          <a:latin typeface="Calibri" pitchFamily="34" charset="0"/>
-                          <a:ea typeface="Calibri" pitchFamily="34" charset="-122"/>
-                          <a:cs typeface="Calibri" pitchFamily="34" charset="-120"/>
-                        </a:rPr>
-                        <a:t>Liquidity / early exit</a:t>
-                      </a:r>
-                      <a:endParaRPr lang="en-US" sz="1050" dirty="0">
-                        <a:latin typeface="Calibri" charset="0"/>
-                        <a:ea typeface="Calibri" charset="0"/>
-                        <a:cs typeface="Calibri" charset="0"/>
-                      </a:endParaRPr>
-                    </a:p>
-                  </a:txBody>
-                  <a:tcPr marL="91440" marR="91440" marT="45720" marB="45720" anchor="ctr">
-                    <a:lnL w="6350" cap="flat" cmpd="sng" algn="ctr">
-                      <a:solidFill>
-                        <a:srgbClr val="D9D2E9"/>
-                      </a:solidFill>
-                      <a:prstDash val="solid"/>
-                      <a:round/>
-                      <a:headEnd type="none" w="med" len="med"/>
-                      <a:tailEnd type="none" w="med" len="med"/>
-                    </a:lnL>
-                    <a:lnR w="6350" cap="flat" cmpd="sng" algn="ctr">
-                      <a:solidFill>
-                        <a:srgbClr val="D9D2E9"/>
-                      </a:solidFill>
-                      <a:prstDash val="solid"/>
-                      <a:round/>
-                      <a:headEnd type="none" w="med" len="med"/>
-                      <a:tailEnd type="none" w="med" len="med"/>
-                    </a:lnR>
-                    <a:lnT w="6350" cap="flat" cmpd="sng" algn="ctr">
-                      <a:solidFill>
-                        <a:srgbClr val="D9D2E9"/>
-                      </a:solidFill>
-                      <a:prstDash val="solid"/>
-                      <a:round/>
-                      <a:headEnd type="none" w="med" len="med"/>
-                      <a:tailEnd type="none" w="med" len="med"/>
-                    </a:lnT>
-                    <a:lnB w="6350" cap="flat" cmpd="sng" algn="ctr">
-                      <a:solidFill>
-                        <a:srgbClr val="D9D2E9"/>
-                      </a:solidFill>
-                      <a:prstDash val="solid"/>
-                      <a:round/>
-                      <a:headEnd type="none" w="med" len="med"/>
-                      <a:tailEnd type="none" w="med" len="med"/>
-                    </a:lnB>
-                    <a:solidFill>
-                      <a:srgbClr val="EEE8F7"/>
-                    </a:solidFill>
-                  </a:tcPr>
-                </a:tc>
-                <a:tc>
-                  <a:txBody>
-                    <a:bodyPr/>
-                    <a:lstStyle/>
-                    <a:p>
-                      <a:pPr indent="0" marL="0">
-                        <a:buNone/>
-                      </a:pPr>
-                      <a:r>
-                        <a:rPr lang="en-US" sz="1050" dirty="0">
-                          <a:solidFill>
-                            <a:srgbClr val="1F1B2D"/>
-                          </a:solidFill>
-                          <a:latin typeface="Calibri" pitchFamily="34" charset="0"/>
-                          <a:ea typeface="Calibri" pitchFamily="34" charset="-122"/>
-                          <a:cs typeface="Calibri" pitchFamily="34" charset="-120"/>
-                        </a:rPr>
-                        <a:t>Unwind at market value, below 90% possible</a:t>
-                      </a:r>
-                      <a:endParaRPr lang="en-US" sz="1050" dirty="0">
-                        <a:latin typeface="Calibri" charset="0"/>
-                        <a:ea typeface="Calibri" charset="0"/>
-                        <a:cs typeface="Calibri" charset="0"/>
-                      </a:endParaRPr>
-                    </a:p>
-                  </a:txBody>
-                  <a:tcPr marL="91440" marR="91440" marT="45720" marB="45720" anchor="ctr">
-                    <a:lnL w="6350" cap="flat" cmpd="sng" algn="ctr">
-                      <a:solidFill>
-                        <a:srgbClr val="D9D2E9"/>
-                      </a:solidFill>
-                      <a:prstDash val="solid"/>
-                      <a:round/>
-                      <a:headEnd type="none" w="med" len="med"/>
-                      <a:tailEnd type="none" w="med" len="med"/>
-                    </a:lnL>
-                    <a:lnR w="6350" cap="flat" cmpd="sng" algn="ctr">
-                      <a:solidFill>
-                        <a:srgbClr val="D9D2E9"/>
-                      </a:solidFill>
-                      <a:prstDash val="solid"/>
-                      <a:round/>
-                      <a:headEnd type="none" w="med" len="med"/>
-                      <a:tailEnd type="none" w="med" len="med"/>
-                    </a:lnR>
-                    <a:lnT w="6350" cap="flat" cmpd="sng" algn="ctr">
-                      <a:solidFill>
-                        <a:srgbClr val="D9D2E9"/>
-                      </a:solidFill>
-                      <a:prstDash val="solid"/>
-                      <a:round/>
-                      <a:headEnd type="none" w="med" len="med"/>
-                      <a:tailEnd type="none" w="med" len="med"/>
-                    </a:lnT>
-                    <a:lnB w="6350" cap="flat" cmpd="sng" algn="ctr">
-                      <a:solidFill>
-                        <a:srgbClr val="D9D2E9"/>
-                      </a:solidFill>
-                      <a:prstDash val="solid"/>
-                      <a:round/>
-                      <a:headEnd type="none" w="med" len="med"/>
-                      <a:tailEnd type="none" w="med" len="med"/>
-                    </a:lnB>
-                    <a:solidFill>
-                      <a:srgbClr val="EEE8F7"/>
-                    </a:solidFill>
-                  </a:tcPr>
-                </a:tc>
-                <a:tc>
-                  <a:txBody>
-                    <a:bodyPr/>
-                    <a:lstStyle/>
-                    <a:p>
-                      <a:pPr indent="0" marL="0">
-                        <a:buNone/>
-                      </a:pPr>
-                      <a:r>
-                        <a:rPr lang="en-US" sz="1050" dirty="0">
-                          <a:solidFill>
-                            <a:srgbClr val="1F1B2D"/>
-                          </a:solidFill>
-                          <a:latin typeface="Calibri" pitchFamily="34" charset="0"/>
-                          <a:ea typeface="Calibri" pitchFamily="34" charset="-122"/>
-                          <a:cs typeface="Calibri" pitchFamily="34" charset="-120"/>
-                        </a:rPr>
-                        <a:t>Natixis secondary market with stated bid/offer</a:t>
-                      </a:r>
-                      <a:endParaRPr lang="en-US" sz="1050" dirty="0">
-                        <a:latin typeface="Calibri" charset="0"/>
-                        <a:ea typeface="Calibri" charset="0"/>
-                        <a:cs typeface="Calibri" charset="0"/>
-                      </a:endParaRPr>
-                    </a:p>
-                  </a:txBody>
-                  <a:tcPr marL="91440" marR="91440" marT="45720" marB="45720" anchor="ctr">
-                    <a:lnL w="6350" cap="flat" cmpd="sng" algn="ctr">
-                      <a:solidFill>
-                        <a:srgbClr val="D9D2E9"/>
-                      </a:solidFill>
-                      <a:prstDash val="solid"/>
-                      <a:round/>
-                      <a:headEnd type="none" w="med" len="med"/>
-                      <a:tailEnd type="none" w="med" len="med"/>
-                    </a:lnL>
-                    <a:lnR w="6350" cap="flat" cmpd="sng" algn="ctr">
-                      <a:solidFill>
-                        <a:srgbClr val="D9D2E9"/>
-                      </a:solidFill>
-                      <a:prstDash val="solid"/>
-                      <a:round/>
-                      <a:headEnd type="none" w="med" len="med"/>
-                      <a:tailEnd type="none" w="med" len="med"/>
-                    </a:lnR>
-                    <a:lnT w="6350" cap="flat" cmpd="sng" algn="ctr">
-                      <a:solidFill>
-                        <a:srgbClr val="D9D2E9"/>
-                      </a:solidFill>
-                      <a:prstDash val="solid"/>
-                      <a:round/>
-                      <a:headEnd type="none" w="med" len="med"/>
-                      <a:tailEnd type="none" w="med" len="med"/>
-                    </a:lnT>
-                    <a:lnB w="6350" cap="flat" cmpd="sng" algn="ctr">
-                      <a:solidFill>
-                        <a:srgbClr val="D9D2E9"/>
-                      </a:solidFill>
-                      <a:prstDash val="solid"/>
-                      <a:round/>
-                      <a:headEnd type="none" w="med" len="med"/>
-                      <a:tailEnd type="none" w="med" len="med"/>
-                    </a:lnB>
-                    <a:solidFill>
-                      <a:srgbClr val="EEE8F7"/>
-                    </a:solidFill>
-                  </a:tcPr>
-                </a:tc>
-              </a:tr>
-              <a:tr h="438912">
-                <a:tc>
-                  <a:txBody>
-                    <a:bodyPr/>
-                    <a:lstStyle/>
-                    <a:p>
-                      <a:pPr indent="0" marL="0">
-                        <a:buNone/>
-                      </a:pPr>
-                      <a:r>
-                        <a:rPr lang="en-US" sz="1050" b="1" dirty="0">
-                          <a:solidFill>
-                            <a:srgbClr val="1F1B2D"/>
-                          </a:solidFill>
-                          <a:latin typeface="Calibri" pitchFamily="34" charset="0"/>
-                          <a:ea typeface="Calibri" pitchFamily="34" charset="-122"/>
-                          <a:cs typeface="Calibri" pitchFamily="34" charset="-120"/>
-                        </a:rPr>
-                        <a:t>KRW mechanics</a:t>
-                      </a:r>
-                      <a:endParaRPr lang="en-US" sz="1050" dirty="0">
-                        <a:latin typeface="Calibri" charset="0"/>
-                        <a:ea typeface="Calibri" charset="0"/>
-                        <a:cs typeface="Calibri" charset="0"/>
-                      </a:endParaRPr>
-                    </a:p>
-                  </a:txBody>
-                  <a:tcPr marL="91440" marR="91440" marT="45720" marB="45720" anchor="ctr">
-                    <a:lnL w="6350" cap="flat" cmpd="sng" algn="ctr">
-                      <a:solidFill>
-                        <a:srgbClr val="D9D2E9"/>
-                      </a:solidFill>
-                      <a:prstDash val="solid"/>
-                      <a:round/>
-                      <a:headEnd type="none" w="med" len="med"/>
-                      <a:tailEnd type="none" w="med" len="med"/>
-                    </a:lnL>
-                    <a:lnR w="6350" cap="flat" cmpd="sng" algn="ctr">
-                      <a:solidFill>
-                        <a:srgbClr val="D9D2E9"/>
-                      </a:solidFill>
-                      <a:prstDash val="solid"/>
-                      <a:round/>
-                      <a:headEnd type="none" w="med" len="med"/>
-                      <a:tailEnd type="none" w="med" len="med"/>
-                    </a:lnR>
-                    <a:lnT w="6350" cap="flat" cmpd="sng" algn="ctr">
-                      <a:solidFill>
-                        <a:srgbClr val="D9D2E9"/>
-                      </a:solidFill>
-                      <a:prstDash val="solid"/>
-                      <a:round/>
-                      <a:headEnd type="none" w="med" len="med"/>
-                      <a:tailEnd type="none" w="med" len="med"/>
-                    </a:lnT>
-                    <a:lnB w="6350" cap="flat" cmpd="sng" algn="ctr">
-                      <a:solidFill>
-                        <a:srgbClr val="D9D2E9"/>
-                      </a:solidFill>
-                      <a:prstDash val="solid"/>
-                      <a:round/>
-                      <a:headEnd type="none" w="med" len="med"/>
-                      <a:tailEnd type="none" w="med" len="med"/>
-                    </a:lnB>
-                    <a:solidFill>
-                      <a:srgbClr val="FFFFFF"/>
-                    </a:solidFill>
-                  </a:tcPr>
-                </a:tc>
-                <a:tc>
-                  <a:txBody>
-                    <a:bodyPr/>
-                    <a:lstStyle/>
-                    <a:p>
-                      <a:pPr indent="0" marL="0">
-                        <a:buNone/>
-                      </a:pPr>
-                      <a:r>
-                        <a:rPr lang="en-US" sz="1050" dirty="0">
-                          <a:solidFill>
-                            <a:srgbClr val="1F1B2D"/>
-                          </a:solidFill>
-                          <a:latin typeface="Calibri" pitchFamily="34" charset="0"/>
-                          <a:ea typeface="Calibri" pitchFamily="34" charset="-122"/>
-                          <a:cs typeface="Calibri" pitchFamily="34" charset="-120"/>
-                        </a:rPr>
-                        <a:t>Cross-currency basis, offshore non-deliverability</a:t>
-                      </a:r>
-                      <a:endParaRPr lang="en-US" sz="1050" dirty="0">
-                        <a:latin typeface="Calibri" charset="0"/>
-                        <a:ea typeface="Calibri" charset="0"/>
-                        <a:cs typeface="Calibri" charset="0"/>
-                      </a:endParaRPr>
-                    </a:p>
-                  </a:txBody>
-                  <a:tcPr marL="91440" marR="91440" marT="45720" marB="45720" anchor="ctr">
-                    <a:lnL w="6350" cap="flat" cmpd="sng" algn="ctr">
-                      <a:solidFill>
-                        <a:srgbClr val="D9D2E9"/>
-                      </a:solidFill>
-                      <a:prstDash val="solid"/>
-                      <a:round/>
-                      <a:headEnd type="none" w="med" len="med"/>
-                      <a:tailEnd type="none" w="med" len="med"/>
-                    </a:lnL>
-                    <a:lnR w="6350" cap="flat" cmpd="sng" algn="ctr">
-                      <a:solidFill>
-                        <a:srgbClr val="D9D2E9"/>
-                      </a:solidFill>
-                      <a:prstDash val="solid"/>
-                      <a:round/>
-                      <a:headEnd type="none" w="med" len="med"/>
-                      <a:tailEnd type="none" w="med" len="med"/>
-                    </a:lnR>
-                    <a:lnT w="6350" cap="flat" cmpd="sng" algn="ctr">
-                      <a:solidFill>
-                        <a:srgbClr val="D9D2E9"/>
-                      </a:solidFill>
-                      <a:prstDash val="solid"/>
-                      <a:round/>
-                      <a:headEnd type="none" w="med" len="med"/>
-                      <a:tailEnd type="none" w="med" len="med"/>
-                    </a:lnT>
-                    <a:lnB w="6350" cap="flat" cmpd="sng" algn="ctr">
-                      <a:solidFill>
-                        <a:srgbClr val="D9D2E9"/>
-                      </a:solidFill>
-                      <a:prstDash val="solid"/>
-                      <a:round/>
-                      <a:headEnd type="none" w="med" len="med"/>
-                      <a:tailEnd type="none" w="med" len="med"/>
-                    </a:lnB>
-                    <a:solidFill>
-                      <a:srgbClr val="FFFFFF"/>
-                    </a:solidFill>
-                  </a:tcPr>
-                </a:tc>
-                <a:tc>
-                  <a:txBody>
-                    <a:bodyPr/>
-                    <a:lstStyle/>
-                    <a:p>
-                      <a:pPr indent="0" marL="0">
-                        <a:buNone/>
-                      </a:pPr>
-                      <a:r>
-                        <a:rPr lang="en-US" sz="1050" dirty="0">
-                          <a:solidFill>
-                            <a:srgbClr val="1F1B2D"/>
-                          </a:solidFill>
-                          <a:latin typeface="Calibri" pitchFamily="34" charset="0"/>
-                          <a:ea typeface="Calibri" pitchFamily="34" charset="-122"/>
-                          <a:cs typeface="Calibri" pitchFamily="34" charset="-120"/>
-                        </a:rPr>
-                        <a:t>KRW-linked settlement terms agreed upfront</a:t>
-                      </a:r>
-                      <a:endParaRPr lang="en-US" sz="1050" dirty="0">
+                      <a:endParaRPr lang="en-US" sz="950" dirty="0">
                         <a:latin typeface="Calibri" charset="0"/>
                         <a:ea typeface="Calibri" charset="0"/>
                         <a:cs typeface="Calibri" charset="0"/>
@@ -5554,7 +5483,556 @@
       </p:graphicFrame>
       <p:sp>
         <p:nvSpPr>
-          <p:cNvPr id="5" name="Text 2"/>
+          <p:cNvPr id="10" name="Text 7"/>
+          <p:cNvSpPr txBox="1"/>
+          <p:nvPr/>
+        </p:nvSpPr>
+        <p:spPr>
+          <a:xfrm>
+            <a:off x="6080760" y="1280160"/>
+            <a:ext cx="2606040" cy="274320"/>
+          </a:xfrm>
+          <a:prstGeom prst="rect">
+            <a:avLst/>
+          </a:prstGeom>
+          <a:noFill/>
+          <a:ln/>
+        </p:spPr>
+        <p:txBody>
+          <a:bodyPr wrap="square" lIns="0" tIns="0" rIns="0" bIns="0" rtlCol="0" anchor="ctr"/>
+          <a:lstStyle/>
+          <a:p>
+            <a:pPr indent="0" marL="0">
+              <a:buNone/>
+            </a:pPr>
+            <a:r>
+              <a:rPr lang="en-US" sz="1250" b="1" dirty="0">
+                <a:solidFill>
+                  <a:srgbClr val="2A1650"/>
+                </a:solidFill>
+                <a:latin typeface="Cambria" pitchFamily="34" charset="0"/>
+                <a:ea typeface="Cambria" pitchFamily="34" charset="-122"/>
+                <a:cs typeface="Cambria" pitchFamily="34" charset="-120"/>
+              </a:rPr>
+              <a:t>Instant stress: MTM change</a:t>
+            </a:r>
+            <a:endParaRPr lang="en-US" sz="1250" dirty="0"/>
+          </a:p>
+        </p:txBody>
+      </p:sp>
+      <p:sp>
+        <p:nvSpPr>
+          <p:cNvPr id="11" name="Shape 8"/>
+          <p:cNvSpPr/>
+          <p:nvPr/>
+        </p:nvSpPr>
+        <p:spPr>
+          <a:xfrm>
+            <a:off x="6080760" y="1600200"/>
+            <a:ext cx="2606040" cy="749808"/>
+          </a:xfrm>
+          <a:prstGeom prst="roundRect">
+            <a:avLst>
+              <a:gd name="adj" fmla="val 9756"/>
+            </a:avLst>
+          </a:prstGeom>
+          <a:solidFill>
+            <a:srgbClr val="EEE8F7"/>
+          </a:solidFill>
+          <a:ln w="12700">
+            <a:solidFill>
+              <a:srgbClr val="EEE8F7"/>
+            </a:solidFill>
+            <a:prstDash val="solid"/>
+          </a:ln>
+        </p:spPr>
+      </p:sp>
+      <p:sp>
+        <p:nvSpPr>
+          <p:cNvPr id="12" name="Text 9"/>
+          <p:cNvSpPr txBox="1"/>
+          <p:nvPr/>
+        </p:nvSpPr>
+        <p:spPr>
+          <a:xfrm>
+            <a:off x="6217920" y="1664208"/>
+            <a:ext cx="1371600" cy="274320"/>
+          </a:xfrm>
+          <a:prstGeom prst="rect">
+            <a:avLst/>
+          </a:prstGeom>
+          <a:noFill/>
+          <a:ln/>
+        </p:spPr>
+        <p:txBody>
+          <a:bodyPr wrap="square" lIns="0" tIns="0" rIns="0" bIns="0" rtlCol="0" anchor="ctr"/>
+          <a:lstStyle/>
+          <a:p>
+            <a:pPr indent="0" marL="0">
+              <a:buNone/>
+            </a:pPr>
+            <a:r>
+              <a:rPr lang="en-US" sz="1200" b="1" dirty="0">
+                <a:solidFill>
+                  <a:srgbClr val="1F1B2D"/>
+                </a:solidFill>
+                <a:latin typeface="Calibri" pitchFamily="34" charset="0"/>
+                <a:ea typeface="Calibri" pitchFamily="34" charset="-122"/>
+                <a:cs typeface="Calibri" pitchFamily="34" charset="-120"/>
+              </a:rPr>
+              <a:t>Risk-off</a:t>
+            </a:r>
+            <a:endParaRPr lang="en-US" sz="1200" dirty="0"/>
+          </a:p>
+        </p:txBody>
+      </p:sp>
+      <p:sp>
+        <p:nvSpPr>
+          <p:cNvPr id="13" name="Text 10"/>
+          <p:cNvSpPr txBox="1"/>
+          <p:nvPr/>
+        </p:nvSpPr>
+        <p:spPr>
+          <a:xfrm>
+            <a:off x="7498080" y="1664208"/>
+            <a:ext cx="1097280" cy="274320"/>
+          </a:xfrm>
+          <a:prstGeom prst="rect">
+            <a:avLst/>
+          </a:prstGeom>
+          <a:noFill/>
+          <a:ln/>
+        </p:spPr>
+        <p:txBody>
+          <a:bodyPr wrap="square" lIns="0" tIns="0" rIns="0" bIns="0" rtlCol="0" anchor="ctr"/>
+          <a:lstStyle/>
+          <a:p>
+            <a:pPr algn="r" indent="0" marL="0">
+              <a:buNone/>
+            </a:pPr>
+            <a:r>
+              <a:rPr lang="en-US" sz="1200" b="1" dirty="0">
+                <a:solidFill>
+                  <a:srgbClr val="1F1B2D"/>
+                </a:solidFill>
+                <a:latin typeface="Calibri" pitchFamily="34" charset="0"/>
+                <a:ea typeface="Calibri" pitchFamily="34" charset="-122"/>
+                <a:cs typeface="Calibri" pitchFamily="34" charset="-120"/>
+              </a:rPr>
+              <a:t>−0.3 pts</a:t>
+            </a:r>
+            <a:endParaRPr lang="en-US" sz="1200" dirty="0"/>
+          </a:p>
+        </p:txBody>
+      </p:sp>
+      <p:sp>
+        <p:nvSpPr>
+          <p:cNvPr id="14" name="Text 11"/>
+          <p:cNvSpPr txBox="1"/>
+          <p:nvPr/>
+        </p:nvSpPr>
+        <p:spPr>
+          <a:xfrm>
+            <a:off x="6217920" y="1947672"/>
+            <a:ext cx="2377440" cy="365760"/>
+          </a:xfrm>
+          <a:prstGeom prst="rect">
+            <a:avLst/>
+          </a:prstGeom>
+          <a:noFill/>
+          <a:ln/>
+        </p:spPr>
+        <p:txBody>
+          <a:bodyPr wrap="square" lIns="0" tIns="0" rIns="0" bIns="0" rtlCol="0" anchor="ctr"/>
+          <a:lstStyle/>
+          <a:p>
+            <a:pPr indent="0" marL="0">
+              <a:buNone/>
+            </a:pPr>
+            <a:r>
+              <a:rPr lang="en-US" sz="950" dirty="0">
+                <a:solidFill>
+                  <a:srgbClr val="6B6680"/>
+                </a:solidFill>
+                <a:latin typeface="Calibri" pitchFamily="34" charset="0"/>
+                <a:ea typeface="Calibri" pitchFamily="34" charset="-122"/>
+                <a:cs typeface="Calibri" pitchFamily="34" charset="-120"/>
+              </a:rPr>
+              <a:t>KOSPI −20%, KRW −5%, vols +10 pts, rates +50 bp</a:t>
+            </a:r>
+            <a:endParaRPr lang="en-US" sz="950" dirty="0"/>
+          </a:p>
+        </p:txBody>
+      </p:sp>
+      <p:sp>
+        <p:nvSpPr>
+          <p:cNvPr id="15" name="Shape 12"/>
+          <p:cNvSpPr/>
+          <p:nvPr/>
+        </p:nvSpPr>
+        <p:spPr>
+          <a:xfrm>
+            <a:off x="6080760" y="2468880"/>
+            <a:ext cx="2606040" cy="749808"/>
+          </a:xfrm>
+          <a:prstGeom prst="roundRect">
+            <a:avLst>
+              <a:gd name="adj" fmla="val 9756"/>
+            </a:avLst>
+          </a:prstGeom>
+          <a:solidFill>
+            <a:srgbClr val="EEE8F7"/>
+          </a:solidFill>
+          <a:ln w="12700">
+            <a:solidFill>
+              <a:srgbClr val="EEE8F7"/>
+            </a:solidFill>
+            <a:prstDash val="solid"/>
+          </a:ln>
+        </p:spPr>
+      </p:sp>
+      <p:sp>
+        <p:nvSpPr>
+          <p:cNvPr id="16" name="Text 13"/>
+          <p:cNvSpPr txBox="1"/>
+          <p:nvPr/>
+        </p:nvSpPr>
+        <p:spPr>
+          <a:xfrm>
+            <a:off x="6217920" y="2532888"/>
+            <a:ext cx="1371600" cy="274320"/>
+          </a:xfrm>
+          <a:prstGeom prst="rect">
+            <a:avLst/>
+          </a:prstGeom>
+          <a:noFill/>
+          <a:ln/>
+        </p:spPr>
+        <p:txBody>
+          <a:bodyPr wrap="square" lIns="0" tIns="0" rIns="0" bIns="0" rtlCol="0" anchor="ctr"/>
+          <a:lstStyle/>
+          <a:p>
+            <a:pPr indent="0" marL="0">
+              <a:buNone/>
+            </a:pPr>
+            <a:r>
+              <a:rPr lang="en-US" sz="1200" b="1" dirty="0">
+                <a:solidFill>
+                  <a:srgbClr val="1F1B2D"/>
+                </a:solidFill>
+                <a:latin typeface="Calibri" pitchFamily="34" charset="0"/>
+                <a:ea typeface="Calibri" pitchFamily="34" charset="-122"/>
+                <a:cs typeface="Calibri" pitchFamily="34" charset="-120"/>
+              </a:rPr>
+              <a:t>Oil shock</a:t>
+            </a:r>
+            <a:endParaRPr lang="en-US" sz="1200" dirty="0"/>
+          </a:p>
+        </p:txBody>
+      </p:sp>
+      <p:sp>
+        <p:nvSpPr>
+          <p:cNvPr id="17" name="Text 14"/>
+          <p:cNvSpPr txBox="1"/>
+          <p:nvPr/>
+        </p:nvSpPr>
+        <p:spPr>
+          <a:xfrm>
+            <a:off x="7498080" y="2532888"/>
+            <a:ext cx="1097280" cy="274320"/>
+          </a:xfrm>
+          <a:prstGeom prst="rect">
+            <a:avLst/>
+          </a:prstGeom>
+          <a:noFill/>
+          <a:ln/>
+        </p:spPr>
+        <p:txBody>
+          <a:bodyPr wrap="square" lIns="0" tIns="0" rIns="0" bIns="0" rtlCol="0" anchor="ctr"/>
+          <a:lstStyle/>
+          <a:p>
+            <a:pPr algn="r" indent="0" marL="0">
+              <a:buNone/>
+            </a:pPr>
+            <a:r>
+              <a:rPr lang="en-US" sz="1200" b="1" dirty="0">
+                <a:solidFill>
+                  <a:srgbClr val="1E9E8F"/>
+                </a:solidFill>
+                <a:latin typeface="Calibri" pitchFamily="34" charset="0"/>
+                <a:ea typeface="Calibri" pitchFamily="34" charset="-122"/>
+                <a:cs typeface="Calibri" pitchFamily="34" charset="-120"/>
+              </a:rPr>
+              <a:t>+13.0 pts</a:t>
+            </a:r>
+            <a:endParaRPr lang="en-US" sz="1200" dirty="0"/>
+          </a:p>
+        </p:txBody>
+      </p:sp>
+      <p:sp>
+        <p:nvSpPr>
+          <p:cNvPr id="18" name="Text 15"/>
+          <p:cNvSpPr txBox="1"/>
+          <p:nvPr/>
+        </p:nvSpPr>
+        <p:spPr>
+          <a:xfrm>
+            <a:off x="6217920" y="2816352"/>
+            <a:ext cx="2377440" cy="365760"/>
+          </a:xfrm>
+          <a:prstGeom prst="rect">
+            <a:avLst/>
+          </a:prstGeom>
+          <a:noFill/>
+          <a:ln/>
+        </p:spPr>
+        <p:txBody>
+          <a:bodyPr wrap="square" lIns="0" tIns="0" rIns="0" bIns="0" rtlCol="0" anchor="ctr"/>
+          <a:lstStyle/>
+          <a:p>
+            <a:pPr indent="0" marL="0">
+              <a:buNone/>
+            </a:pPr>
+            <a:r>
+              <a:rPr lang="en-US" sz="950" dirty="0">
+                <a:solidFill>
+                  <a:srgbClr val="6B6680"/>
+                </a:solidFill>
+                <a:latin typeface="Calibri" pitchFamily="34" charset="0"/>
+                <a:ea typeface="Calibri" pitchFamily="34" charset="-122"/>
+                <a:cs typeface="Calibri" pitchFamily="34" charset="-120"/>
+              </a:rPr>
+              <a:t>Brent +30%, KOSPI −10%, vols +8 pts</a:t>
+            </a:r>
+            <a:endParaRPr lang="en-US" sz="950" dirty="0"/>
+          </a:p>
+        </p:txBody>
+      </p:sp>
+      <p:sp>
+        <p:nvSpPr>
+          <p:cNvPr id="19" name="Shape 16"/>
+          <p:cNvSpPr/>
+          <p:nvPr/>
+        </p:nvSpPr>
+        <p:spPr>
+          <a:xfrm>
+            <a:off x="6080760" y="3337560"/>
+            <a:ext cx="2606040" cy="749808"/>
+          </a:xfrm>
+          <a:prstGeom prst="roundRect">
+            <a:avLst>
+              <a:gd name="adj" fmla="val 9756"/>
+            </a:avLst>
+          </a:prstGeom>
+          <a:solidFill>
+            <a:srgbClr val="EEE8F7"/>
+          </a:solidFill>
+          <a:ln w="12700">
+            <a:solidFill>
+              <a:srgbClr val="EEE8F7"/>
+            </a:solidFill>
+            <a:prstDash val="solid"/>
+          </a:ln>
+        </p:spPr>
+      </p:sp>
+      <p:sp>
+        <p:nvSpPr>
+          <p:cNvPr id="20" name="Text 17"/>
+          <p:cNvSpPr txBox="1"/>
+          <p:nvPr/>
+        </p:nvSpPr>
+        <p:spPr>
+          <a:xfrm>
+            <a:off x="6217920" y="3401568"/>
+            <a:ext cx="1371600" cy="274320"/>
+          </a:xfrm>
+          <a:prstGeom prst="rect">
+            <a:avLst/>
+          </a:prstGeom>
+          <a:noFill/>
+          <a:ln/>
+        </p:spPr>
+        <p:txBody>
+          <a:bodyPr wrap="square" lIns="0" tIns="0" rIns="0" bIns="0" rtlCol="0" anchor="ctr"/>
+          <a:lstStyle/>
+          <a:p>
+            <a:pPr indent="0" marL="0">
+              <a:buNone/>
+            </a:pPr>
+            <a:r>
+              <a:rPr lang="en-US" sz="1200" b="1" dirty="0">
+                <a:solidFill>
+                  <a:srgbClr val="1F1B2D"/>
+                </a:solidFill>
+                <a:latin typeface="Calibri" pitchFamily="34" charset="0"/>
+                <a:ea typeface="Calibri" pitchFamily="34" charset="-122"/>
+                <a:cs typeface="Calibri" pitchFamily="34" charset="-120"/>
+              </a:rPr>
+              <a:t>Ceasefire</a:t>
+            </a:r>
+            <a:endParaRPr lang="en-US" sz="1200" dirty="0"/>
+          </a:p>
+        </p:txBody>
+      </p:sp>
+      <p:sp>
+        <p:nvSpPr>
+          <p:cNvPr id="21" name="Text 18"/>
+          <p:cNvSpPr txBox="1"/>
+          <p:nvPr/>
+        </p:nvSpPr>
+        <p:spPr>
+          <a:xfrm>
+            <a:off x="7498080" y="3401568"/>
+            <a:ext cx="1097280" cy="274320"/>
+          </a:xfrm>
+          <a:prstGeom prst="rect">
+            <a:avLst/>
+          </a:prstGeom>
+          <a:noFill/>
+          <a:ln/>
+        </p:spPr>
+        <p:txBody>
+          <a:bodyPr wrap="square" lIns="0" tIns="0" rIns="0" bIns="0" rtlCol="0" anchor="ctr"/>
+          <a:lstStyle/>
+          <a:p>
+            <a:pPr algn="r" indent="0" marL="0">
+              <a:buNone/>
+            </a:pPr>
+            <a:r>
+              <a:rPr lang="en-US" sz="1200" b="1" dirty="0">
+                <a:solidFill>
+                  <a:srgbClr val="C8463D"/>
+                </a:solidFill>
+                <a:latin typeface="Calibri" pitchFamily="34" charset="0"/>
+                <a:ea typeface="Calibri" pitchFamily="34" charset="-122"/>
+                <a:cs typeface="Calibri" pitchFamily="34" charset="-120"/>
+              </a:rPr>
+              <a:t>−2.9 pts</a:t>
+            </a:r>
+            <a:endParaRPr lang="en-US" sz="1200" dirty="0"/>
+          </a:p>
+        </p:txBody>
+      </p:sp>
+      <p:sp>
+        <p:nvSpPr>
+          <p:cNvPr id="22" name="Text 19"/>
+          <p:cNvSpPr txBox="1"/>
+          <p:nvPr/>
+        </p:nvSpPr>
+        <p:spPr>
+          <a:xfrm>
+            <a:off x="6217920" y="3685032"/>
+            <a:ext cx="2377440" cy="365760"/>
+          </a:xfrm>
+          <a:prstGeom prst="rect">
+            <a:avLst/>
+          </a:prstGeom>
+          <a:noFill/>
+          <a:ln/>
+        </p:spPr>
+        <p:txBody>
+          <a:bodyPr wrap="square" lIns="0" tIns="0" rIns="0" bIns="0" rtlCol="0" anchor="ctr"/>
+          <a:lstStyle/>
+          <a:p>
+            <a:pPr indent="0" marL="0">
+              <a:buNone/>
+            </a:pPr>
+            <a:r>
+              <a:rPr lang="en-US" sz="950" dirty="0">
+                <a:solidFill>
+                  <a:srgbClr val="6B6680"/>
+                </a:solidFill>
+                <a:latin typeface="Calibri" pitchFamily="34" charset="0"/>
+                <a:ea typeface="Calibri" pitchFamily="34" charset="-122"/>
+                <a:cs typeface="Calibri" pitchFamily="34" charset="-120"/>
+              </a:rPr>
+              <a:t>Brent −20%, KOSPI +10%, vols −3 pts</a:t>
+            </a:r>
+            <a:endParaRPr lang="en-US" sz="950" dirty="0"/>
+          </a:p>
+        </p:txBody>
+      </p:sp>
+      <p:sp>
+        <p:nvSpPr>
+          <p:cNvPr id="23" name="Text 20"/>
+          <p:cNvSpPr txBox="1"/>
+          <p:nvPr/>
+        </p:nvSpPr>
+        <p:spPr>
+          <a:xfrm>
+            <a:off x="6080760" y="4224528"/>
+            <a:ext cx="2606040" cy="411480"/>
+          </a:xfrm>
+          <a:prstGeom prst="rect">
+            <a:avLst/>
+          </a:prstGeom>
+          <a:noFill/>
+          <a:ln/>
+        </p:spPr>
+        <p:txBody>
+          <a:bodyPr wrap="square" lIns="0" tIns="0" rIns="0" bIns="0" rtlCol="0" anchor="ctr"/>
+          <a:lstStyle/>
+          <a:p>
+            <a:pPr indent="0" marL="0">
+              <a:buNone/>
+            </a:pPr>
+            <a:r>
+              <a:rPr lang="en-US" sz="950" i="1" dirty="0">
+                <a:solidFill>
+                  <a:srgbClr val="4B2E83"/>
+                </a:solidFill>
+                <a:latin typeface="Calibri" pitchFamily="34" charset="0"/>
+                <a:ea typeface="Calibri" pitchFamily="34" charset="-122"/>
+                <a:cs typeface="Calibri" pitchFamily="34" charset="-120"/>
+              </a:rPr>
+              <a:t>Long vega cushions the risk-off case: higher vol lifts Engine A.</a:t>
+            </a:r>
+            <a:endParaRPr lang="en-US" sz="950" dirty="0"/>
+          </a:p>
+        </p:txBody>
+      </p:sp>
+      <p:sp>
+        <p:nvSpPr>
+          <p:cNvPr id="24" name="Text 21"/>
+          <p:cNvSpPr txBox="1"/>
+          <p:nvPr/>
+        </p:nvSpPr>
+        <p:spPr>
+          <a:xfrm>
+            <a:off x="457200" y="4754880"/>
+            <a:ext cx="7680960" cy="274320"/>
+          </a:xfrm>
+          <a:prstGeom prst="rect">
+            <a:avLst/>
+          </a:prstGeom>
+          <a:noFill/>
+          <a:ln/>
+        </p:spPr>
+        <p:txBody>
+          <a:bodyPr wrap="square" lIns="0" tIns="0" rIns="0" bIns="0" rtlCol="0" anchor="ctr"/>
+          <a:lstStyle/>
+          <a:p>
+            <a:pPr indent="0" marL="0">
+              <a:buNone/>
+            </a:pPr>
+            <a:r>
+              <a:rPr lang="en-US" sz="850" i="1" dirty="0">
+                <a:solidFill>
+                  <a:srgbClr val="6B6680"/>
+                </a:solidFill>
+                <a:latin typeface="Calibri" pitchFamily="34" charset="0"/>
+                <a:ea typeface="Calibri" pitchFamily="34" charset="-122"/>
+                <a:cs typeface="Calibri" pitchFamily="34" charset="-120"/>
+              </a:rPr>
+              <a:t>Placeholder inputs; USD/KRW ≈ 1,390 assumed. Delta-normal VaR overstates risk for a convex note; early exit can be below the 90% floor.</a:t>
+            </a:r>
+            <a:endParaRPr lang="en-US" sz="850" dirty="0"/>
+          </a:p>
+        </p:txBody>
+      </p:sp>
+      <p:sp>
+        <p:nvSpPr>
+          <p:cNvPr id="25" name="Text 22"/>
           <p:cNvSpPr txBox="1"/>
           <p:nvPr/>
         </p:nvSpPr>
@@ -5605,7 +6083,7 @@
     <p:bg>
       <p:bgPr>
         <a:solidFill>
-          <a:srgbClr val="2A1650"/>
+          <a:srgbClr val="FFFFFF"/>
         </a:solidFill>
       </p:bgPr>
     </p:bg>
@@ -5625,33 +6103,13 @@
       </p:grpSpPr>
       <p:sp>
         <p:nvSpPr>
-          <p:cNvPr id="2" name="Shape 0"/>
-          <p:cNvSpPr/>
-          <p:nvPr/>
-        </p:nvSpPr>
-        <p:spPr>
-          <a:xfrm>
-            <a:off x="6766560" y="2926080"/>
-            <a:ext cx="3291840" cy="3291840"/>
-          </a:xfrm>
-          <a:prstGeom prst="ellipse">
-            <a:avLst/>
-          </a:prstGeom>
-          <a:solidFill>
-            <a:srgbClr val="4B2E83"/>
-          </a:solidFill>
-          <a:ln/>
-        </p:spPr>
-      </p:sp>
-      <p:sp>
-        <p:nvSpPr>
-          <p:cNvPr id="3" name="Text 1"/>
+          <p:cNvPr id="2" name="Text 0"/>
           <p:cNvSpPr txBox="1"/>
           <p:nvPr/>
         </p:nvSpPr>
         <p:spPr>
           <a:xfrm>
-            <a:off x="457200" y="320040"/>
+            <a:off x="457200" y="274320"/>
             <a:ext cx="8229600" cy="548640"/>
           </a:xfrm>
           <a:prstGeom prst="rect">
@@ -5670,13 +6128,13 @@
             <a:r>
               <a:rPr lang="en-US" sz="2800" b="1" dirty="0">
                 <a:solidFill>
-                  <a:srgbClr val="FFFFFF"/>
+                  <a:srgbClr val="2A1650"/>
                 </a:solidFill>
                 <a:latin typeface="Cambria" pitchFamily="34" charset="0"/>
                 <a:ea typeface="Cambria" pitchFamily="34" charset="-122"/>
                 <a:cs typeface="Cambria" pitchFamily="34" charset="-120"/>
               </a:rPr>
-              <a:t>Why it fits Purple Magic</a:t>
+              <a:t>Risk register and exit plan</a:t>
             </a:r>
             <a:endParaRPr lang="en-US" sz="2800" dirty="0"/>
           </a:p>
@@ -5684,13 +6142,910 @@
       </p:sp>
       <p:sp>
         <p:nvSpPr>
-          <p:cNvPr id="4" name="Shape 2"/>
+          <p:cNvPr id="3" name="Text 1"/>
+          <p:cNvSpPr txBox="1"/>
+          <p:nvPr/>
+        </p:nvSpPr>
+        <p:spPr>
+          <a:xfrm>
+            <a:off x="457200" y="804672"/>
+            <a:ext cx="8229600" cy="320040"/>
+          </a:xfrm>
+          <a:prstGeom prst="rect">
+            <a:avLst/>
+          </a:prstGeom>
+          <a:noFill/>
+          <a:ln/>
+        </p:spPr>
+        <p:txBody>
+          <a:bodyPr wrap="square" lIns="0" tIns="0" rIns="0" bIns="0" rtlCol="0" anchor="ctr"/>
+          <a:lstStyle/>
+          <a:p>
+            <a:pPr indent="0" marL="0">
+              <a:buNone/>
+            </a:pPr>
+            <a:r>
+              <a:rPr lang="en-US" sz="1300" i="1" dirty="0">
+                <a:solidFill>
+                  <a:srgbClr val="6B6680"/>
+                </a:solidFill>
+                <a:latin typeface="Calibri" pitchFamily="34" charset="0"/>
+                <a:ea typeface="Calibri" pitchFamily="34" charset="-122"/>
+                <a:cs typeface="Calibri" pitchFamily="34" charset="-120"/>
+              </a:rPr>
+              <a:t>Every risk named, and four exits defined in advance</a:t>
+            </a:r>
+            <a:endParaRPr lang="en-US" sz="1300" dirty="0"/>
+          </a:p>
+        </p:txBody>
+      </p:sp>
+      <p:graphicFrame>
+        <p:nvGraphicFramePr>
+          <p:cNvPr id="13" name="Table 0"/>
+          <p:cNvGraphicFramePr>
+            <a:graphicFrameLocks noGrp="1"/>
+          </p:cNvGraphicFramePr>
+          <p:nvPr>
+            <p:extLst>
+              <p:ext uri="{D42A27DB-BD31-4B8C-83A1-F6EECF244321}">
+                <p14:modId xmlns:p14="http://schemas.microsoft.com/office/powerpoint/2010/main" val="1579011935"/>
+              </p:ext>
+            </p:extLst>
+          </p:nvPr>
+        </p:nvGraphicFramePr>
+        <p:xfrm>
+          <a:off x="457200" y="1280160"/>
+          <a:ext cx="4480560" cy="914400"/>
+        </p:xfrm>
+        <a:graphic>
+          <a:graphicData uri="http://schemas.openxmlformats.org/drawingml/2006/table">
+            <a:tbl>
+              <a:tblPr/>
+              <a:tblGrid>
+                <a:gridCol w="1143000"/>
+                <a:gridCol w="3337560"/>
+              </a:tblGrid>
+              <a:tr h="548640">
+                <a:tc>
+                  <a:txBody>
+                    <a:bodyPr/>
+                    <a:lstStyle/>
+                    <a:p>
+                      <a:pPr indent="0" marL="0">
+                        <a:buNone/>
+                      </a:pPr>
+                      <a:r>
+                        <a:rPr lang="en-US" sz="950" b="1" dirty="0">
+                          <a:solidFill>
+                            <a:srgbClr val="FFFFFF"/>
+                          </a:solidFill>
+                          <a:latin typeface="Calibri" pitchFamily="34" charset="0"/>
+                          <a:ea typeface="Calibri" pitchFamily="34" charset="-122"/>
+                          <a:cs typeface="Calibri" pitchFamily="34" charset="-120"/>
+                        </a:rPr>
+                        <a:t>Risk</a:t>
+                      </a:r>
+                      <a:endParaRPr lang="en-US" sz="950" dirty="0">
+                        <a:latin typeface="Calibri" charset="0"/>
+                        <a:ea typeface="Calibri" charset="0"/>
+                        <a:cs typeface="Calibri" charset="0"/>
+                      </a:endParaRPr>
+                    </a:p>
+                  </a:txBody>
+                  <a:tcPr marL="91440" marR="91440" marT="45720" marB="45720" anchor="ctr">
+                    <a:lnL w="6350" cap="flat" cmpd="sng" algn="ctr">
+                      <a:solidFill>
+                        <a:srgbClr val="D9D2E9"/>
+                      </a:solidFill>
+                      <a:prstDash val="solid"/>
+                      <a:round/>
+                      <a:headEnd type="none" w="med" len="med"/>
+                      <a:tailEnd type="none" w="med" len="med"/>
+                    </a:lnL>
+                    <a:lnR w="6350" cap="flat" cmpd="sng" algn="ctr">
+                      <a:solidFill>
+                        <a:srgbClr val="D9D2E9"/>
+                      </a:solidFill>
+                      <a:prstDash val="solid"/>
+                      <a:round/>
+                      <a:headEnd type="none" w="med" len="med"/>
+                      <a:tailEnd type="none" w="med" len="med"/>
+                    </a:lnR>
+                    <a:lnT w="6350" cap="flat" cmpd="sng" algn="ctr">
+                      <a:solidFill>
+                        <a:srgbClr val="D9D2E9"/>
+                      </a:solidFill>
+                      <a:prstDash val="solid"/>
+                      <a:round/>
+                      <a:headEnd type="none" w="med" len="med"/>
+                      <a:tailEnd type="none" w="med" len="med"/>
+                    </a:lnT>
+                    <a:lnB w="6350" cap="flat" cmpd="sng" algn="ctr">
+                      <a:solidFill>
+                        <a:srgbClr val="D9D2E9"/>
+                      </a:solidFill>
+                      <a:prstDash val="solid"/>
+                      <a:round/>
+                      <a:headEnd type="none" w="med" len="med"/>
+                      <a:tailEnd type="none" w="med" len="med"/>
+                    </a:lnB>
+                    <a:solidFill>
+                      <a:srgbClr val="2A1650"/>
+                    </a:solidFill>
+                  </a:tcPr>
+                </a:tc>
+                <a:tc>
+                  <a:txBody>
+                    <a:bodyPr/>
+                    <a:lstStyle/>
+                    <a:p>
+                      <a:pPr indent="0" marL="0">
+                        <a:buNone/>
+                      </a:pPr>
+                      <a:r>
+                        <a:rPr lang="en-US" sz="950" b="1" dirty="0">
+                          <a:solidFill>
+                            <a:srgbClr val="FFFFFF"/>
+                          </a:solidFill>
+                          <a:latin typeface="Calibri" pitchFamily="34" charset="0"/>
+                          <a:ea typeface="Calibri" pitchFamily="34" charset="-122"/>
+                          <a:cs typeface="Calibri" pitchFamily="34" charset="-120"/>
+                        </a:rPr>
+                        <a:t>Assessment and mitigant</a:t>
+                      </a:r>
+                      <a:endParaRPr lang="en-US" sz="950" dirty="0">
+                        <a:latin typeface="Calibri" charset="0"/>
+                        <a:ea typeface="Calibri" charset="0"/>
+                        <a:cs typeface="Calibri" charset="0"/>
+                      </a:endParaRPr>
+                    </a:p>
+                  </a:txBody>
+                  <a:tcPr marL="91440" marR="91440" marT="45720" marB="45720" anchor="ctr">
+                    <a:lnL w="6350" cap="flat" cmpd="sng" algn="ctr">
+                      <a:solidFill>
+                        <a:srgbClr val="D9D2E9"/>
+                      </a:solidFill>
+                      <a:prstDash val="solid"/>
+                      <a:round/>
+                      <a:headEnd type="none" w="med" len="med"/>
+                      <a:tailEnd type="none" w="med" len="med"/>
+                    </a:lnL>
+                    <a:lnR w="6350" cap="flat" cmpd="sng" algn="ctr">
+                      <a:solidFill>
+                        <a:srgbClr val="D9D2E9"/>
+                      </a:solidFill>
+                      <a:prstDash val="solid"/>
+                      <a:round/>
+                      <a:headEnd type="none" w="med" len="med"/>
+                      <a:tailEnd type="none" w="med" len="med"/>
+                    </a:lnR>
+                    <a:lnT w="6350" cap="flat" cmpd="sng" algn="ctr">
+                      <a:solidFill>
+                        <a:srgbClr val="D9D2E9"/>
+                      </a:solidFill>
+                      <a:prstDash val="solid"/>
+                      <a:round/>
+                      <a:headEnd type="none" w="med" len="med"/>
+                      <a:tailEnd type="none" w="med" len="med"/>
+                    </a:lnT>
+                    <a:lnB w="6350" cap="flat" cmpd="sng" algn="ctr">
+                      <a:solidFill>
+                        <a:srgbClr val="D9D2E9"/>
+                      </a:solidFill>
+                      <a:prstDash val="solid"/>
+                      <a:round/>
+                      <a:headEnd type="none" w="med" len="med"/>
+                      <a:tailEnd type="none" w="med" len="med"/>
+                    </a:lnB>
+                    <a:solidFill>
+                      <a:srgbClr val="2A1650"/>
+                    </a:solidFill>
+                  </a:tcPr>
+                </a:tc>
+              </a:tr>
+              <a:tr h="548640">
+                <a:tc>
+                  <a:txBody>
+                    <a:bodyPr/>
+                    <a:lstStyle/>
+                    <a:p>
+                      <a:pPr indent="0" marL="0">
+                        <a:buNone/>
+                      </a:pPr>
+                      <a:r>
+                        <a:rPr lang="en-US" sz="950" b="1" dirty="0">
+                          <a:solidFill>
+                            <a:srgbClr val="1F1B2D"/>
+                          </a:solidFill>
+                          <a:latin typeface="Calibri" pitchFamily="34" charset="0"/>
+                          <a:ea typeface="Calibri" pitchFamily="34" charset="-122"/>
+                          <a:cs typeface="Calibri" pitchFamily="34" charset="-120"/>
+                        </a:rPr>
+                        <a:t>Model</a:t>
+                      </a:r>
+                      <a:endParaRPr lang="en-US" sz="950" dirty="0">
+                        <a:latin typeface="Calibri" charset="0"/>
+                        <a:ea typeface="Calibri" charset="0"/>
+                        <a:cs typeface="Calibri" charset="0"/>
+                      </a:endParaRPr>
+                    </a:p>
+                  </a:txBody>
+                  <a:tcPr marL="91440" marR="91440" marT="45720" marB="45720" anchor="ctr">
+                    <a:lnL w="6350" cap="flat" cmpd="sng" algn="ctr">
+                      <a:solidFill>
+                        <a:srgbClr val="D9D2E9"/>
+                      </a:solidFill>
+                      <a:prstDash val="solid"/>
+                      <a:round/>
+                      <a:headEnd type="none" w="med" len="med"/>
+                      <a:tailEnd type="none" w="med" len="med"/>
+                    </a:lnL>
+                    <a:lnR w="6350" cap="flat" cmpd="sng" algn="ctr">
+                      <a:solidFill>
+                        <a:srgbClr val="D9D2E9"/>
+                      </a:solidFill>
+                      <a:prstDash val="solid"/>
+                      <a:round/>
+                      <a:headEnd type="none" w="med" len="med"/>
+                      <a:tailEnd type="none" w="med" len="med"/>
+                    </a:lnR>
+                    <a:lnT w="6350" cap="flat" cmpd="sng" algn="ctr">
+                      <a:solidFill>
+                        <a:srgbClr val="D9D2E9"/>
+                      </a:solidFill>
+                      <a:prstDash val="solid"/>
+                      <a:round/>
+                      <a:headEnd type="none" w="med" len="med"/>
+                      <a:tailEnd type="none" w="med" len="med"/>
+                    </a:lnT>
+                    <a:lnB w="6350" cap="flat" cmpd="sng" algn="ctr">
+                      <a:solidFill>
+                        <a:srgbClr val="D9D2E9"/>
+                      </a:solidFill>
+                      <a:prstDash val="solid"/>
+                      <a:round/>
+                      <a:headEnd type="none" w="med" len="med"/>
+                      <a:tailEnd type="none" w="med" len="med"/>
+                    </a:lnB>
+                    <a:solidFill>
+                      <a:srgbClr val="EEE8F7"/>
+                    </a:solidFill>
+                  </a:tcPr>
+                </a:tc>
+                <a:tc>
+                  <a:txBody>
+                    <a:bodyPr/>
+                    <a:lstStyle/>
+                    <a:p>
+                      <a:pPr indent="0" marL="0">
+                        <a:buNone/>
+                      </a:pPr>
+                      <a:r>
+                        <a:rPr lang="en-US" sz="950" dirty="0">
+                          <a:solidFill>
+                            <a:srgbClr val="1F1B2D"/>
+                          </a:solidFill>
+                          <a:latin typeface="Calibri" pitchFamily="34" charset="0"/>
+                          <a:ea typeface="Calibri" pitchFamily="34" charset="-122"/>
+                          <a:cs typeface="Calibri" pitchFamily="34" charset="-120"/>
+                        </a:rPr>
+                        <a:t>Correlation and skew drive B and C. Price with surface vols; show correlation sensitivity</a:t>
+                      </a:r>
+                      <a:endParaRPr lang="en-US" sz="950" dirty="0">
+                        <a:latin typeface="Calibri" charset="0"/>
+                        <a:ea typeface="Calibri" charset="0"/>
+                        <a:cs typeface="Calibri" charset="0"/>
+                      </a:endParaRPr>
+                    </a:p>
+                  </a:txBody>
+                  <a:tcPr marL="91440" marR="91440" marT="45720" marB="45720" anchor="ctr">
+                    <a:lnL w="6350" cap="flat" cmpd="sng" algn="ctr">
+                      <a:solidFill>
+                        <a:srgbClr val="D9D2E9"/>
+                      </a:solidFill>
+                      <a:prstDash val="solid"/>
+                      <a:round/>
+                      <a:headEnd type="none" w="med" len="med"/>
+                      <a:tailEnd type="none" w="med" len="med"/>
+                    </a:lnL>
+                    <a:lnR w="6350" cap="flat" cmpd="sng" algn="ctr">
+                      <a:solidFill>
+                        <a:srgbClr val="D9D2E9"/>
+                      </a:solidFill>
+                      <a:prstDash val="solid"/>
+                      <a:round/>
+                      <a:headEnd type="none" w="med" len="med"/>
+                      <a:tailEnd type="none" w="med" len="med"/>
+                    </a:lnR>
+                    <a:lnT w="6350" cap="flat" cmpd="sng" algn="ctr">
+                      <a:solidFill>
+                        <a:srgbClr val="D9D2E9"/>
+                      </a:solidFill>
+                      <a:prstDash val="solid"/>
+                      <a:round/>
+                      <a:headEnd type="none" w="med" len="med"/>
+                      <a:tailEnd type="none" w="med" len="med"/>
+                    </a:lnT>
+                    <a:lnB w="6350" cap="flat" cmpd="sng" algn="ctr">
+                      <a:solidFill>
+                        <a:srgbClr val="D9D2E9"/>
+                      </a:solidFill>
+                      <a:prstDash val="solid"/>
+                      <a:round/>
+                      <a:headEnd type="none" w="med" len="med"/>
+                      <a:tailEnd type="none" w="med" len="med"/>
+                    </a:lnB>
+                    <a:solidFill>
+                      <a:srgbClr val="EEE8F7"/>
+                    </a:solidFill>
+                  </a:tcPr>
+                </a:tc>
+              </a:tr>
+              <a:tr h="548640">
+                <a:tc>
+                  <a:txBody>
+                    <a:bodyPr/>
+                    <a:lstStyle/>
+                    <a:p>
+                      <a:pPr indent="0" marL="0">
+                        <a:buNone/>
+                      </a:pPr>
+                      <a:r>
+                        <a:rPr lang="en-US" sz="950" b="1" dirty="0">
+                          <a:solidFill>
+                            <a:srgbClr val="1F1B2D"/>
+                          </a:solidFill>
+                          <a:latin typeface="Calibri" pitchFamily="34" charset="0"/>
+                          <a:ea typeface="Calibri" pitchFamily="34" charset="-122"/>
+                          <a:cs typeface="Calibri" pitchFamily="34" charset="-120"/>
+                        </a:rPr>
+                        <a:t>Liquidity</a:t>
+                      </a:r>
+                      <a:endParaRPr lang="en-US" sz="950" dirty="0">
+                        <a:latin typeface="Calibri" charset="0"/>
+                        <a:ea typeface="Calibri" charset="0"/>
+                        <a:cs typeface="Calibri" charset="0"/>
+                      </a:endParaRPr>
+                    </a:p>
+                  </a:txBody>
+                  <a:tcPr marL="91440" marR="91440" marT="45720" marB="45720" anchor="ctr">
+                    <a:lnL w="6350" cap="flat" cmpd="sng" algn="ctr">
+                      <a:solidFill>
+                        <a:srgbClr val="D9D2E9"/>
+                      </a:solidFill>
+                      <a:prstDash val="solid"/>
+                      <a:round/>
+                      <a:headEnd type="none" w="med" len="med"/>
+                      <a:tailEnd type="none" w="med" len="med"/>
+                    </a:lnL>
+                    <a:lnR w="6350" cap="flat" cmpd="sng" algn="ctr">
+                      <a:solidFill>
+                        <a:srgbClr val="D9D2E9"/>
+                      </a:solidFill>
+                      <a:prstDash val="solid"/>
+                      <a:round/>
+                      <a:headEnd type="none" w="med" len="med"/>
+                      <a:tailEnd type="none" w="med" len="med"/>
+                    </a:lnR>
+                    <a:lnT w="6350" cap="flat" cmpd="sng" algn="ctr">
+                      <a:solidFill>
+                        <a:srgbClr val="D9D2E9"/>
+                      </a:solidFill>
+                      <a:prstDash val="solid"/>
+                      <a:round/>
+                      <a:headEnd type="none" w="med" len="med"/>
+                      <a:tailEnd type="none" w="med" len="med"/>
+                    </a:lnT>
+                    <a:lnB w="6350" cap="flat" cmpd="sng" algn="ctr">
+                      <a:solidFill>
+                        <a:srgbClr val="D9D2E9"/>
+                      </a:solidFill>
+                      <a:prstDash val="solid"/>
+                      <a:round/>
+                      <a:headEnd type="none" w="med" len="med"/>
+                      <a:tailEnd type="none" w="med" len="med"/>
+                    </a:lnB>
+                    <a:solidFill>
+                      <a:srgbClr val="FFFFFF"/>
+                    </a:solidFill>
+                  </a:tcPr>
+                </a:tc>
+                <a:tc>
+                  <a:txBody>
+                    <a:bodyPr/>
+                    <a:lstStyle/>
+                    <a:p>
+                      <a:pPr indent="0" marL="0">
+                        <a:buNone/>
+                      </a:pPr>
+                      <a:r>
+                        <a:rPr lang="en-US" sz="950" dirty="0">
+                          <a:solidFill>
+                            <a:srgbClr val="1F1B2D"/>
+                          </a:solidFill>
+                          <a:latin typeface="Calibri" pitchFamily="34" charset="0"/>
+                          <a:ea typeface="Calibri" pitchFamily="34" charset="-122"/>
+                          <a:cs typeface="Calibri" pitchFamily="34" charset="-120"/>
+                        </a:rPr>
+                        <a:t>OTC note: ~1.9% margin in, ~1% bid/offer out. Hedges trade in deep KOSPI 200, Brent and USD/KRW markets</a:t>
+                      </a:r>
+                      <a:endParaRPr lang="en-US" sz="950" dirty="0">
+                        <a:latin typeface="Calibri" charset="0"/>
+                        <a:ea typeface="Calibri" charset="0"/>
+                        <a:cs typeface="Calibri" charset="0"/>
+                      </a:endParaRPr>
+                    </a:p>
+                  </a:txBody>
+                  <a:tcPr marL="91440" marR="91440" marT="45720" marB="45720" anchor="ctr">
+                    <a:lnL w="6350" cap="flat" cmpd="sng" algn="ctr">
+                      <a:solidFill>
+                        <a:srgbClr val="D9D2E9"/>
+                      </a:solidFill>
+                      <a:prstDash val="solid"/>
+                      <a:round/>
+                      <a:headEnd type="none" w="med" len="med"/>
+                      <a:tailEnd type="none" w="med" len="med"/>
+                    </a:lnL>
+                    <a:lnR w="6350" cap="flat" cmpd="sng" algn="ctr">
+                      <a:solidFill>
+                        <a:srgbClr val="D9D2E9"/>
+                      </a:solidFill>
+                      <a:prstDash val="solid"/>
+                      <a:round/>
+                      <a:headEnd type="none" w="med" len="med"/>
+                      <a:tailEnd type="none" w="med" len="med"/>
+                    </a:lnR>
+                    <a:lnT w="6350" cap="flat" cmpd="sng" algn="ctr">
+                      <a:solidFill>
+                        <a:srgbClr val="D9D2E9"/>
+                      </a:solidFill>
+                      <a:prstDash val="solid"/>
+                      <a:round/>
+                      <a:headEnd type="none" w="med" len="med"/>
+                      <a:tailEnd type="none" w="med" len="med"/>
+                    </a:lnT>
+                    <a:lnB w="6350" cap="flat" cmpd="sng" algn="ctr">
+                      <a:solidFill>
+                        <a:srgbClr val="D9D2E9"/>
+                      </a:solidFill>
+                      <a:prstDash val="solid"/>
+                      <a:round/>
+                      <a:headEnd type="none" w="med" len="med"/>
+                      <a:tailEnd type="none" w="med" len="med"/>
+                    </a:lnB>
+                    <a:solidFill>
+                      <a:srgbClr val="FFFFFF"/>
+                    </a:solidFill>
+                  </a:tcPr>
+                </a:tc>
+              </a:tr>
+              <a:tr h="548640">
+                <a:tc>
+                  <a:txBody>
+                    <a:bodyPr/>
+                    <a:lstStyle/>
+                    <a:p>
+                      <a:pPr indent="0" marL="0">
+                        <a:buNone/>
+                      </a:pPr>
+                      <a:r>
+                        <a:rPr lang="en-US" sz="950" b="1" dirty="0">
+                          <a:solidFill>
+                            <a:srgbClr val="1F1B2D"/>
+                          </a:solidFill>
+                          <a:latin typeface="Calibri" pitchFamily="34" charset="0"/>
+                          <a:ea typeface="Calibri" pitchFamily="34" charset="-122"/>
+                          <a:cs typeface="Calibri" pitchFamily="34" charset="-120"/>
+                        </a:rPr>
+                        <a:t>Counterparty</a:t>
+                      </a:r>
+                      <a:endParaRPr lang="en-US" sz="950" dirty="0">
+                        <a:latin typeface="Calibri" charset="0"/>
+                        <a:ea typeface="Calibri" charset="0"/>
+                        <a:cs typeface="Calibri" charset="0"/>
+                      </a:endParaRPr>
+                    </a:p>
+                  </a:txBody>
+                  <a:tcPr marL="91440" marR="91440" marT="45720" marB="45720" anchor="ctr">
+                    <a:lnL w="6350" cap="flat" cmpd="sng" algn="ctr">
+                      <a:solidFill>
+                        <a:srgbClr val="D9D2E9"/>
+                      </a:solidFill>
+                      <a:prstDash val="solid"/>
+                      <a:round/>
+                      <a:headEnd type="none" w="med" len="med"/>
+                      <a:tailEnd type="none" w="med" len="med"/>
+                    </a:lnL>
+                    <a:lnR w="6350" cap="flat" cmpd="sng" algn="ctr">
+                      <a:solidFill>
+                        <a:srgbClr val="D9D2E9"/>
+                      </a:solidFill>
+                      <a:prstDash val="solid"/>
+                      <a:round/>
+                      <a:headEnd type="none" w="med" len="med"/>
+                      <a:tailEnd type="none" w="med" len="med"/>
+                    </a:lnR>
+                    <a:lnT w="6350" cap="flat" cmpd="sng" algn="ctr">
+                      <a:solidFill>
+                        <a:srgbClr val="D9D2E9"/>
+                      </a:solidFill>
+                      <a:prstDash val="solid"/>
+                      <a:round/>
+                      <a:headEnd type="none" w="med" len="med"/>
+                      <a:tailEnd type="none" w="med" len="med"/>
+                    </a:lnT>
+                    <a:lnB w="6350" cap="flat" cmpd="sng" algn="ctr">
+                      <a:solidFill>
+                        <a:srgbClr val="D9D2E9"/>
+                      </a:solidFill>
+                      <a:prstDash val="solid"/>
+                      <a:round/>
+                      <a:headEnd type="none" w="med" len="med"/>
+                      <a:tailEnd type="none" w="med" len="med"/>
+                    </a:lnB>
+                    <a:solidFill>
+                      <a:srgbClr val="EEE8F7"/>
+                    </a:solidFill>
+                  </a:tcPr>
+                </a:tc>
+                <a:tc>
+                  <a:txBody>
+                    <a:bodyPr/>
+                    <a:lstStyle/>
+                    <a:p>
+                      <a:pPr indent="0" marL="0">
+                        <a:buNone/>
+                      </a:pPr>
+                      <a:r>
+                        <a:rPr lang="en-US" sz="950" dirty="0">
+                          <a:solidFill>
+                            <a:srgbClr val="1F1B2D"/>
+                          </a:solidFill>
+                          <a:latin typeface="Calibri" pitchFamily="34" charset="0"/>
+                          <a:ea typeface="Calibri" pitchFamily="34" charset="-122"/>
+                          <a:cs typeface="Calibri" pitchFamily="34" charset="-120"/>
+                        </a:rPr>
+                        <a:t>Natixis issuer risk: disclose rating and CDS. ISDA/CSA for the OTC hedges</a:t>
+                      </a:r>
+                      <a:endParaRPr lang="en-US" sz="950" dirty="0">
+                        <a:latin typeface="Calibri" charset="0"/>
+                        <a:ea typeface="Calibri" charset="0"/>
+                        <a:cs typeface="Calibri" charset="0"/>
+                      </a:endParaRPr>
+                    </a:p>
+                  </a:txBody>
+                  <a:tcPr marL="91440" marR="91440" marT="45720" marB="45720" anchor="ctr">
+                    <a:lnL w="6350" cap="flat" cmpd="sng" algn="ctr">
+                      <a:solidFill>
+                        <a:srgbClr val="D9D2E9"/>
+                      </a:solidFill>
+                      <a:prstDash val="solid"/>
+                      <a:round/>
+                      <a:headEnd type="none" w="med" len="med"/>
+                      <a:tailEnd type="none" w="med" len="med"/>
+                    </a:lnL>
+                    <a:lnR w="6350" cap="flat" cmpd="sng" algn="ctr">
+                      <a:solidFill>
+                        <a:srgbClr val="D9D2E9"/>
+                      </a:solidFill>
+                      <a:prstDash val="solid"/>
+                      <a:round/>
+                      <a:headEnd type="none" w="med" len="med"/>
+                      <a:tailEnd type="none" w="med" len="med"/>
+                    </a:lnR>
+                    <a:lnT w="6350" cap="flat" cmpd="sng" algn="ctr">
+                      <a:solidFill>
+                        <a:srgbClr val="D9D2E9"/>
+                      </a:solidFill>
+                      <a:prstDash val="solid"/>
+                      <a:round/>
+                      <a:headEnd type="none" w="med" len="med"/>
+                      <a:tailEnd type="none" w="med" len="med"/>
+                    </a:lnT>
+                    <a:lnB w="6350" cap="flat" cmpd="sng" algn="ctr">
+                      <a:solidFill>
+                        <a:srgbClr val="D9D2E9"/>
+                      </a:solidFill>
+                      <a:prstDash val="solid"/>
+                      <a:round/>
+                      <a:headEnd type="none" w="med" len="med"/>
+                      <a:tailEnd type="none" w="med" len="med"/>
+                    </a:lnB>
+                    <a:solidFill>
+                      <a:srgbClr val="EEE8F7"/>
+                    </a:solidFill>
+                  </a:tcPr>
+                </a:tc>
+              </a:tr>
+              <a:tr h="548640">
+                <a:tc>
+                  <a:txBody>
+                    <a:bodyPr/>
+                    <a:lstStyle/>
+                    <a:p>
+                      <a:pPr indent="0" marL="0">
+                        <a:buNone/>
+                      </a:pPr>
+                      <a:r>
+                        <a:rPr lang="en-US" sz="950" b="1" dirty="0">
+                          <a:solidFill>
+                            <a:srgbClr val="1F1B2D"/>
+                          </a:solidFill>
+                          <a:latin typeface="Calibri" pitchFamily="34" charset="0"/>
+                          <a:ea typeface="Calibri" pitchFamily="34" charset="-122"/>
+                          <a:cs typeface="Calibri" pitchFamily="34" charset="-120"/>
+                        </a:rPr>
+                        <a:t>Operational</a:t>
+                      </a:r>
+                      <a:endParaRPr lang="en-US" sz="950" dirty="0">
+                        <a:latin typeface="Calibri" charset="0"/>
+                        <a:ea typeface="Calibri" charset="0"/>
+                        <a:cs typeface="Calibri" charset="0"/>
+                      </a:endParaRPr>
+                    </a:p>
+                  </a:txBody>
+                  <a:tcPr marL="91440" marR="91440" marT="45720" marB="45720" anchor="ctr">
+                    <a:lnL w="6350" cap="flat" cmpd="sng" algn="ctr">
+                      <a:solidFill>
+                        <a:srgbClr val="D9D2E9"/>
+                      </a:solidFill>
+                      <a:prstDash val="solid"/>
+                      <a:round/>
+                      <a:headEnd type="none" w="med" len="med"/>
+                      <a:tailEnd type="none" w="med" len="med"/>
+                    </a:lnL>
+                    <a:lnR w="6350" cap="flat" cmpd="sng" algn="ctr">
+                      <a:solidFill>
+                        <a:srgbClr val="D9D2E9"/>
+                      </a:solidFill>
+                      <a:prstDash val="solid"/>
+                      <a:round/>
+                      <a:headEnd type="none" w="med" len="med"/>
+                      <a:tailEnd type="none" w="med" len="med"/>
+                    </a:lnR>
+                    <a:lnT w="6350" cap="flat" cmpd="sng" algn="ctr">
+                      <a:solidFill>
+                        <a:srgbClr val="D9D2E9"/>
+                      </a:solidFill>
+                      <a:prstDash val="solid"/>
+                      <a:round/>
+                      <a:headEnd type="none" w="med" len="med"/>
+                      <a:tailEnd type="none" w="med" len="med"/>
+                    </a:lnT>
+                    <a:lnB w="6350" cap="flat" cmpd="sng" algn="ctr">
+                      <a:solidFill>
+                        <a:srgbClr val="D9D2E9"/>
+                      </a:solidFill>
+                      <a:prstDash val="solid"/>
+                      <a:round/>
+                      <a:headEnd type="none" w="med" len="med"/>
+                      <a:tailEnd type="none" w="med" len="med"/>
+                    </a:lnB>
+                    <a:solidFill>
+                      <a:srgbClr val="FFFFFF"/>
+                    </a:solidFill>
+                  </a:tcPr>
+                </a:tc>
+                <a:tc>
+                  <a:txBody>
+                    <a:bodyPr/>
+                    <a:lstStyle/>
+                    <a:p>
+                      <a:pPr indent="0" marL="0">
+                        <a:buNone/>
+                      </a:pPr>
+                      <a:r>
+                        <a:rPr lang="en-US" sz="950" dirty="0">
+                          <a:solidFill>
+                            <a:srgbClr val="1F1B2D"/>
+                          </a:solidFill>
+                          <a:latin typeface="Calibri" pitchFamily="34" charset="0"/>
+                          <a:ea typeface="Calibri" pitchFamily="34" charset="-122"/>
+                          <a:cs typeface="Calibri" pitchFamily="34" charset="-120"/>
+                        </a:rPr>
+                        <a:t>Daily Brent trigger monitoring, independent fixing source, monthly MTM report</a:t>
+                      </a:r>
+                      <a:endParaRPr lang="en-US" sz="950" dirty="0">
+                        <a:latin typeface="Calibri" charset="0"/>
+                        <a:ea typeface="Calibri" charset="0"/>
+                        <a:cs typeface="Calibri" charset="0"/>
+                      </a:endParaRPr>
+                    </a:p>
+                  </a:txBody>
+                  <a:tcPr marL="91440" marR="91440" marT="45720" marB="45720" anchor="ctr">
+                    <a:lnL w="6350" cap="flat" cmpd="sng" algn="ctr">
+                      <a:solidFill>
+                        <a:srgbClr val="D9D2E9"/>
+                      </a:solidFill>
+                      <a:prstDash val="solid"/>
+                      <a:round/>
+                      <a:headEnd type="none" w="med" len="med"/>
+                      <a:tailEnd type="none" w="med" len="med"/>
+                    </a:lnL>
+                    <a:lnR w="6350" cap="flat" cmpd="sng" algn="ctr">
+                      <a:solidFill>
+                        <a:srgbClr val="D9D2E9"/>
+                      </a:solidFill>
+                      <a:prstDash val="solid"/>
+                      <a:round/>
+                      <a:headEnd type="none" w="med" len="med"/>
+                      <a:tailEnd type="none" w="med" len="med"/>
+                    </a:lnR>
+                    <a:lnT w="6350" cap="flat" cmpd="sng" algn="ctr">
+                      <a:solidFill>
+                        <a:srgbClr val="D9D2E9"/>
+                      </a:solidFill>
+                      <a:prstDash val="solid"/>
+                      <a:round/>
+                      <a:headEnd type="none" w="med" len="med"/>
+                      <a:tailEnd type="none" w="med" len="med"/>
+                    </a:lnT>
+                    <a:lnB w="6350" cap="flat" cmpd="sng" algn="ctr">
+                      <a:solidFill>
+                        <a:srgbClr val="D9D2E9"/>
+                      </a:solidFill>
+                      <a:prstDash val="solid"/>
+                      <a:round/>
+                      <a:headEnd type="none" w="med" len="med"/>
+                      <a:tailEnd type="none" w="med" len="med"/>
+                    </a:lnB>
+                    <a:solidFill>
+                      <a:srgbClr val="FFFFFF"/>
+                    </a:solidFill>
+                  </a:tcPr>
+                </a:tc>
+              </a:tr>
+              <a:tr h="548640">
+                <a:tc>
+                  <a:txBody>
+                    <a:bodyPr/>
+                    <a:lstStyle/>
+                    <a:p>
+                      <a:pPr indent="0" marL="0">
+                        <a:buNone/>
+                      </a:pPr>
+                      <a:r>
+                        <a:rPr lang="en-US" sz="950" b="1" dirty="0">
+                          <a:solidFill>
+                            <a:srgbClr val="1F1B2D"/>
+                          </a:solidFill>
+                          <a:latin typeface="Calibri" pitchFamily="34" charset="0"/>
+                          <a:ea typeface="Calibri" pitchFamily="34" charset="-122"/>
+                          <a:cs typeface="Calibri" pitchFamily="34" charset="-120"/>
+                        </a:rPr>
+                        <a:t>KRW mechanics</a:t>
+                      </a:r>
+                      <a:endParaRPr lang="en-US" sz="950" dirty="0">
+                        <a:latin typeface="Calibri" charset="0"/>
+                        <a:ea typeface="Calibri" charset="0"/>
+                        <a:cs typeface="Calibri" charset="0"/>
+                      </a:endParaRPr>
+                    </a:p>
+                  </a:txBody>
+                  <a:tcPr marL="91440" marR="91440" marT="45720" marB="45720" anchor="ctr">
+                    <a:lnL w="6350" cap="flat" cmpd="sng" algn="ctr">
+                      <a:solidFill>
+                        <a:srgbClr val="D9D2E9"/>
+                      </a:solidFill>
+                      <a:prstDash val="solid"/>
+                      <a:round/>
+                      <a:headEnd type="none" w="med" len="med"/>
+                      <a:tailEnd type="none" w="med" len="med"/>
+                    </a:lnL>
+                    <a:lnR w="6350" cap="flat" cmpd="sng" algn="ctr">
+                      <a:solidFill>
+                        <a:srgbClr val="D9D2E9"/>
+                      </a:solidFill>
+                      <a:prstDash val="solid"/>
+                      <a:round/>
+                      <a:headEnd type="none" w="med" len="med"/>
+                      <a:tailEnd type="none" w="med" len="med"/>
+                    </a:lnR>
+                    <a:lnT w="6350" cap="flat" cmpd="sng" algn="ctr">
+                      <a:solidFill>
+                        <a:srgbClr val="D9D2E9"/>
+                      </a:solidFill>
+                      <a:prstDash val="solid"/>
+                      <a:round/>
+                      <a:headEnd type="none" w="med" len="med"/>
+                      <a:tailEnd type="none" w="med" len="med"/>
+                    </a:lnT>
+                    <a:lnB w="6350" cap="flat" cmpd="sng" algn="ctr">
+                      <a:solidFill>
+                        <a:srgbClr val="D9D2E9"/>
+                      </a:solidFill>
+                      <a:prstDash val="solid"/>
+                      <a:round/>
+                      <a:headEnd type="none" w="med" len="med"/>
+                      <a:tailEnd type="none" w="med" len="med"/>
+                    </a:lnB>
+                    <a:solidFill>
+                      <a:srgbClr val="EEE8F7"/>
+                    </a:solidFill>
+                  </a:tcPr>
+                </a:tc>
+                <a:tc>
+                  <a:txBody>
+                    <a:bodyPr/>
+                    <a:lstStyle/>
+                    <a:p>
+                      <a:pPr indent="0" marL="0">
+                        <a:buNone/>
+                      </a:pPr>
+                      <a:r>
+                        <a:rPr lang="en-US" sz="950" dirty="0">
+                          <a:solidFill>
+                            <a:srgbClr val="1F1B2D"/>
+                          </a:solidFill>
+                          <a:latin typeface="Calibri" pitchFamily="34" charset="0"/>
+                          <a:ea typeface="Calibri" pitchFamily="34" charset="-122"/>
+                          <a:cs typeface="Calibri" pitchFamily="34" charset="-120"/>
+                        </a:rPr>
+                        <a:t>CCS basis and offshore non-deliverability: settlement terms agreed up front</a:t>
+                      </a:r>
+                      <a:endParaRPr lang="en-US" sz="950" dirty="0">
+                        <a:latin typeface="Calibri" charset="0"/>
+                        <a:ea typeface="Calibri" charset="0"/>
+                        <a:cs typeface="Calibri" charset="0"/>
+                      </a:endParaRPr>
+                    </a:p>
+                  </a:txBody>
+                  <a:tcPr marL="91440" marR="91440" marT="45720" marB="45720" anchor="ctr">
+                    <a:lnL w="6350" cap="flat" cmpd="sng" algn="ctr">
+                      <a:solidFill>
+                        <a:srgbClr val="D9D2E9"/>
+                      </a:solidFill>
+                      <a:prstDash val="solid"/>
+                      <a:round/>
+                      <a:headEnd type="none" w="med" len="med"/>
+                      <a:tailEnd type="none" w="med" len="med"/>
+                    </a:lnL>
+                    <a:lnR w="6350" cap="flat" cmpd="sng" algn="ctr">
+                      <a:solidFill>
+                        <a:srgbClr val="D9D2E9"/>
+                      </a:solidFill>
+                      <a:prstDash val="solid"/>
+                      <a:round/>
+                      <a:headEnd type="none" w="med" len="med"/>
+                      <a:tailEnd type="none" w="med" len="med"/>
+                    </a:lnR>
+                    <a:lnT w="6350" cap="flat" cmpd="sng" algn="ctr">
+                      <a:solidFill>
+                        <a:srgbClr val="D9D2E9"/>
+                      </a:solidFill>
+                      <a:prstDash val="solid"/>
+                      <a:round/>
+                      <a:headEnd type="none" w="med" len="med"/>
+                      <a:tailEnd type="none" w="med" len="med"/>
+                    </a:lnT>
+                    <a:lnB w="6350" cap="flat" cmpd="sng" algn="ctr">
+                      <a:solidFill>
+                        <a:srgbClr val="D9D2E9"/>
+                      </a:solidFill>
+                      <a:prstDash val="solid"/>
+                      <a:round/>
+                      <a:headEnd type="none" w="med" len="med"/>
+                      <a:tailEnd type="none" w="med" len="med"/>
+                    </a:lnB>
+                    <a:solidFill>
+                      <a:srgbClr val="EEE8F7"/>
+                    </a:solidFill>
+                  </a:tcPr>
+                </a:tc>
+              </a:tr>
+            </a:tbl>
+          </a:graphicData>
+        </a:graphic>
+      </p:graphicFrame>
+      <p:sp>
+        <p:nvSpPr>
+          <p:cNvPr id="5" name="Shape 2"/>
           <p:cNvSpPr/>
           <p:nvPr/>
         </p:nvSpPr>
         <p:spPr>
           <a:xfrm>
-            <a:off x="457200" y="1143000"/>
+            <a:off x="5212080" y="1325880"/>
             <a:ext cx="457200" cy="457200"/>
           </a:xfrm>
           <a:prstGeom prst="ellipse">
@@ -5704,13 +7059,13 @@
       </p:sp>
       <p:sp>
         <p:nvSpPr>
-          <p:cNvPr id="5" name="Text 3"/>
+          <p:cNvPr id="6" name="Text 3"/>
           <p:cNvSpPr txBox="1"/>
           <p:nvPr/>
         </p:nvSpPr>
         <p:spPr>
           <a:xfrm>
-            <a:off x="457200" y="1143000"/>
+            <a:off x="5212080" y="1325880"/>
             <a:ext cx="457200" cy="457200"/>
           </a:xfrm>
           <a:prstGeom prst="rect">
@@ -5743,14 +7098,14 @@
       </p:sp>
       <p:sp>
         <p:nvSpPr>
-          <p:cNvPr id="6" name="Text 4"/>
+          <p:cNvPr id="7" name="Text 4"/>
           <p:cNvSpPr txBox="1"/>
           <p:nvPr/>
         </p:nvSpPr>
         <p:spPr>
           <a:xfrm>
-            <a:off x="1097280" y="1097280"/>
-            <a:ext cx="5943600" cy="292608"/>
+            <a:off x="5806440" y="1280160"/>
+            <a:ext cx="2880360" cy="274320"/>
           </a:xfrm>
           <a:prstGeom prst="rect">
             <a:avLst/>
@@ -5766,30 +7121,30 @@
               <a:buNone/>
             </a:pPr>
             <a:r>
-              <a:rPr lang="en-US" sz="1500" b="1" dirty="0">
-                <a:solidFill>
-                  <a:srgbClr val="FFFFFF"/>
+              <a:rPr lang="en-US" sz="1250" b="1" dirty="0">
+                <a:solidFill>
+                  <a:srgbClr val="2A1650"/>
                 </a:solidFill>
                 <a:latin typeface="Calibri" pitchFamily="34" charset="0"/>
                 <a:ea typeface="Calibri" pitchFamily="34" charset="-122"/>
                 <a:cs typeface="Calibri" pitchFamily="34" charset="-120"/>
               </a:rPr>
-              <a:t>Exotic and event-driven</a:t>
-            </a:r>
-            <a:endParaRPr lang="en-US" sz="1500" dirty="0"/>
-          </a:p>
-        </p:txBody>
-      </p:sp>
-      <p:sp>
-        <p:nvSpPr>
-          <p:cNvPr id="7" name="Text 5"/>
+              <a:t>Profit target</a:t>
+            </a:r>
+            <a:endParaRPr lang="en-US" sz="1250" dirty="0"/>
+          </a:p>
+        </p:txBody>
+      </p:sp>
+      <p:sp>
+        <p:nvSpPr>
+          <p:cNvPr id="8" name="Text 5"/>
           <p:cNvSpPr txBox="1"/>
           <p:nvPr/>
         </p:nvSpPr>
         <p:spPr>
           <a:xfrm>
-            <a:off x="1097280" y="1389888"/>
-            <a:ext cx="5943600" cy="274320"/>
+            <a:off x="5806440" y="1554480"/>
+            <a:ext cx="2880360" cy="502920"/>
           </a:xfrm>
           <a:prstGeom prst="rect">
             <a:avLst/>
@@ -5805,29 +7160,29 @@
               <a:buNone/>
             </a:pPr>
             <a:r>
-              <a:rPr lang="en-US" sz="1200" dirty="0">
-                <a:solidFill>
-                  <a:srgbClr val="DCD3EE"/>
+              <a:rPr lang="en-US" sz="1050" dirty="0">
+                <a:solidFill>
+                  <a:srgbClr val="1F1B2D"/>
                 </a:solidFill>
                 <a:latin typeface="Calibri" pitchFamily="34" charset="0"/>
                 <a:ea typeface="Calibri" pitchFamily="34" charset="-122"/>
                 <a:cs typeface="Calibri" pitchFamily="34" charset="-120"/>
               </a:rPr>
-              <a:t>Cross-asset hybrid, dual digital and barrier, all tied to live Korea catalysts</a:t>
-            </a:r>
-            <a:endParaRPr lang="en-US" sz="1200" dirty="0"/>
-          </a:p>
-        </p:txBody>
-      </p:sp>
-      <p:sp>
-        <p:nvSpPr>
-          <p:cNvPr id="8" name="Shape 6"/>
+              <a:t>Sell back to Natixis when MTM ≥ 115% (net of ~1% bid/offer)</a:t>
+            </a:r>
+            <a:endParaRPr lang="en-US" sz="1050" dirty="0"/>
+          </a:p>
+        </p:txBody>
+      </p:sp>
+      <p:sp>
+        <p:nvSpPr>
+          <p:cNvPr id="9" name="Shape 6"/>
           <p:cNvSpPr/>
           <p:nvPr/>
         </p:nvSpPr>
         <p:spPr>
           <a:xfrm>
-            <a:off x="457200" y="1920240"/>
+            <a:off x="5212080" y="2176272"/>
             <a:ext cx="457200" cy="457200"/>
           </a:xfrm>
           <a:prstGeom prst="ellipse">
@@ -5841,13 +7196,13 @@
       </p:sp>
       <p:sp>
         <p:nvSpPr>
-          <p:cNvPr id="9" name="Text 7"/>
+          <p:cNvPr id="10" name="Text 7"/>
           <p:cNvSpPr txBox="1"/>
           <p:nvPr/>
         </p:nvSpPr>
         <p:spPr>
           <a:xfrm>
-            <a:off x="457200" y="1920240"/>
+            <a:off x="5212080" y="2176272"/>
             <a:ext cx="457200" cy="457200"/>
           </a:xfrm>
           <a:prstGeom prst="rect">
@@ -5880,14 +7235,14 @@
       </p:sp>
       <p:sp>
         <p:nvSpPr>
-          <p:cNvPr id="10" name="Text 8"/>
+          <p:cNvPr id="11" name="Text 8"/>
           <p:cNvSpPr txBox="1"/>
           <p:nvPr/>
         </p:nvSpPr>
         <p:spPr>
           <a:xfrm>
-            <a:off x="1097280" y="1874520"/>
-            <a:ext cx="5943600" cy="292608"/>
+            <a:off x="5806440" y="2130552"/>
+            <a:ext cx="2880360" cy="274320"/>
           </a:xfrm>
           <a:prstGeom prst="rect">
             <a:avLst/>
@@ -5903,30 +7258,30 @@
               <a:buNone/>
             </a:pPr>
             <a:r>
-              <a:rPr lang="en-US" sz="1500" b="1" dirty="0">
-                <a:solidFill>
-                  <a:srgbClr val="FFFFFF"/>
+              <a:rPr lang="en-US" sz="1250" b="1" dirty="0">
+                <a:solidFill>
+                  <a:srgbClr val="2A1650"/>
                 </a:solidFill>
                 <a:latin typeface="Calibri" pitchFamily="34" charset="0"/>
                 <a:ea typeface="Calibri" pitchFamily="34" charset="-122"/>
                 <a:cs typeface="Calibri" pitchFamily="34" charset="-120"/>
               </a:rPr>
-              <a:t>Asymmetric</a:t>
-            </a:r>
-            <a:endParaRPr lang="en-US" sz="1500" dirty="0"/>
-          </a:p>
-        </p:txBody>
-      </p:sp>
-      <p:sp>
-        <p:nvSpPr>
-          <p:cNvPr id="11" name="Text 9"/>
+              <a:t>Thesis invalidation</a:t>
+            </a:r>
+            <a:endParaRPr lang="en-US" sz="1250" dirty="0"/>
+          </a:p>
+        </p:txBody>
+      </p:sp>
+      <p:sp>
+        <p:nvSpPr>
+          <p:cNvPr id="12" name="Text 9"/>
           <p:cNvSpPr txBox="1"/>
           <p:nvPr/>
         </p:nvSpPr>
         <p:spPr>
           <a:xfrm>
-            <a:off x="1097280" y="2167128"/>
-            <a:ext cx="5943600" cy="274320"/>
+            <a:off x="5806440" y="2404872"/>
+            <a:ext cx="2880360" cy="502920"/>
           </a:xfrm>
           <a:prstGeom prst="rect">
             <a:avLst/>
@@ -5942,29 +7297,29 @@
               <a:buNone/>
             </a:pPr>
             <a:r>
-              <a:rPr lang="en-US" sz="1200" dirty="0">
-                <a:solidFill>
-                  <a:srgbClr val="DCD3EE"/>
+              <a:rPr lang="en-US" sz="1050" dirty="0">
+                <a:solidFill>
+                  <a:srgbClr val="1F1B2D"/>
                 </a:solidFill>
                 <a:latin typeface="Calibri" pitchFamily="34" charset="0"/>
                 <a:ea typeface="Calibri" pitchFamily="34" charset="-122"/>
                 <a:cs typeface="Calibri" pitchFamily="34" charset="-120"/>
               </a:rPr>
-              <a:t>Convex upside in two regimes, from a 14% option budget</a:t>
-            </a:r>
-            <a:endParaRPr lang="en-US" sz="1200" dirty="0"/>
-          </a:p>
-        </p:txBody>
-      </p:sp>
-      <p:sp>
-        <p:nvSpPr>
-          <p:cNvPr id="12" name="Shape 10"/>
+              <a:t>Exit if WGBI flows reverse and MSCI drops Korea from review, even if P&amp;L is positive</a:t>
+            </a:r>
+            <a:endParaRPr lang="en-US" sz="1050" dirty="0"/>
+          </a:p>
+        </p:txBody>
+      </p:sp>
+      <p:sp>
+        <p:nvSpPr>
+          <p:cNvPr id="13" name="Shape 10"/>
           <p:cNvSpPr/>
           <p:nvPr/>
         </p:nvSpPr>
         <p:spPr>
           <a:xfrm>
-            <a:off x="457200" y="2697480"/>
+            <a:off x="5212080" y="3026664"/>
             <a:ext cx="457200" cy="457200"/>
           </a:xfrm>
           <a:prstGeom prst="ellipse">
@@ -5978,13 +7333,13 @@
       </p:sp>
       <p:sp>
         <p:nvSpPr>
-          <p:cNvPr id="13" name="Text 11"/>
+          <p:cNvPr id="14" name="Text 11"/>
           <p:cNvSpPr txBox="1"/>
           <p:nvPr/>
         </p:nvSpPr>
         <p:spPr>
           <a:xfrm>
-            <a:off x="457200" y="2697480"/>
+            <a:off x="5212080" y="3026664"/>
             <a:ext cx="457200" cy="457200"/>
           </a:xfrm>
           <a:prstGeom prst="rect">
@@ -6017,14 +7372,14 @@
       </p:sp>
       <p:sp>
         <p:nvSpPr>
-          <p:cNvPr id="14" name="Text 12"/>
+          <p:cNvPr id="15" name="Text 12"/>
           <p:cNvSpPr txBox="1"/>
           <p:nvPr/>
         </p:nvSpPr>
         <p:spPr>
           <a:xfrm>
-            <a:off x="1097280" y="2651760"/>
-            <a:ext cx="5943600" cy="292608"/>
+            <a:off x="5806440" y="2980944"/>
+            <a:ext cx="2880360" cy="274320"/>
           </a:xfrm>
           <a:prstGeom prst="rect">
             <a:avLst/>
@@ -6040,30 +7395,30 @@
               <a:buNone/>
             </a:pPr>
             <a:r>
-              <a:rPr lang="en-US" sz="1500" b="1" dirty="0">
-                <a:solidFill>
-                  <a:srgbClr val="FFFFFF"/>
+              <a:rPr lang="en-US" sz="1250" b="1" dirty="0">
+                <a:solidFill>
+                  <a:srgbClr val="2A1650"/>
                 </a:solidFill>
                 <a:latin typeface="Calibri" pitchFamily="34" charset="0"/>
                 <a:ea typeface="Calibri" pitchFamily="34" charset="-122"/>
                 <a:cs typeface="Calibri" pitchFamily="34" charset="-120"/>
               </a:rPr>
-              <a:t>Built for trust</a:t>
-            </a:r>
-            <a:endParaRPr lang="en-US" sz="1500" dirty="0"/>
-          </a:p>
-        </p:txBody>
-      </p:sp>
-      <p:sp>
-        <p:nvSpPr>
-          <p:cNvPr id="15" name="Text 13"/>
+              <a:t>Time stop</a:t>
+            </a:r>
+            <a:endParaRPr lang="en-US" sz="1250" dirty="0"/>
+          </a:p>
+        </p:txBody>
+      </p:sp>
+      <p:sp>
+        <p:nvSpPr>
+          <p:cNvPr id="16" name="Text 13"/>
           <p:cNvSpPr txBox="1"/>
           <p:nvPr/>
         </p:nvSpPr>
         <p:spPr>
           <a:xfrm>
-            <a:off x="1097280" y="2944368"/>
-            <a:ext cx="5943600" cy="274320"/>
+            <a:off x="5806440" y="3255264"/>
+            <a:ext cx="2880360" cy="502920"/>
           </a:xfrm>
           <a:prstGeom prst="rect">
             <a:avLst/>
@@ -6079,30 +7434,50 @@
               <a:buNone/>
             </a:pPr>
             <a:r>
-              <a:rPr lang="en-US" sz="1200" dirty="0">
-                <a:solidFill>
-                  <a:srgbClr val="DCD3EE"/>
+              <a:rPr lang="en-US" sz="1050" dirty="0">
+                <a:solidFill>
+                  <a:srgbClr val="1F1B2D"/>
                 </a:solidFill>
                 <a:latin typeface="Calibri" pitchFamily="34" charset="0"/>
                 <a:ea typeface="Calibri" pitchFamily="34" charset="-122"/>
                 <a:cs typeface="Calibri" pitchFamily="34" charset="-120"/>
               </a:rPr>
-              <a:t>Max loss known on day one, transparent pricing and Greeks</a:t>
-            </a:r>
-            <a:endParaRPr lang="en-US" sz="1200" dirty="0"/>
-          </a:p>
-        </p:txBody>
-      </p:sp>
-      <p:sp>
-        <p:nvSpPr>
-          <p:cNvPr id="16" name="Text 14"/>
+              <a:t>Month 12: Engine A's trigger window closes. Hold or sell back on B and C value</a:t>
+            </a:r>
+            <a:endParaRPr lang="en-US" sz="1050" dirty="0"/>
+          </a:p>
+        </p:txBody>
+      </p:sp>
+      <p:sp>
+        <p:nvSpPr>
+          <p:cNvPr id="17" name="Shape 14"/>
+          <p:cNvSpPr/>
+          <p:nvPr/>
+        </p:nvSpPr>
+        <p:spPr>
+          <a:xfrm>
+            <a:off x="5212080" y="3877056"/>
+            <a:ext cx="457200" cy="457200"/>
+          </a:xfrm>
+          <a:prstGeom prst="ellipse">
+            <a:avLst/>
+          </a:prstGeom>
+          <a:solidFill>
+            <a:srgbClr val="C8463D"/>
+          </a:solidFill>
+          <a:ln/>
+        </p:spPr>
+      </p:sp>
+      <p:sp>
+        <p:nvSpPr>
+          <p:cNvPr id="18" name="Text 15"/>
           <p:cNvSpPr txBox="1"/>
           <p:nvPr/>
         </p:nvSpPr>
         <p:spPr>
           <a:xfrm>
-            <a:off x="457200" y="3520440"/>
-            <a:ext cx="3657600" cy="320040"/>
+            <a:off x="5212080" y="3877056"/>
+            <a:ext cx="457200" cy="457200"/>
           </a:xfrm>
           <a:prstGeom prst="rect">
             <a:avLst/>
@@ -6114,19 +7489,19 @@
           <a:bodyPr wrap="square" lIns="0" tIns="0" rIns="0" bIns="0" rtlCol="0" anchor="ctr"/>
           <a:lstStyle/>
           <a:p>
-            <a:pPr indent="0" marL="0">
+            <a:pPr algn="ctr" indent="0" marL="0">
               <a:buNone/>
             </a:pPr>
             <a:r>
               <a:rPr lang="en-US" sz="1600" b="1" dirty="0">
                 <a:solidFill>
-                  <a:srgbClr val="E8A33D"/>
+                  <a:srgbClr val="FFFFFF"/>
                 </a:solidFill>
                 <a:latin typeface="Cambria" pitchFamily="34" charset="0"/>
                 <a:ea typeface="Cambria" pitchFamily="34" charset="-122"/>
                 <a:cs typeface="Cambria" pitchFamily="34" charset="-120"/>
               </a:rPr>
-              <a:t>Next steps</a:t>
+              <a:t>4</a:t>
             </a:r>
             <a:endParaRPr lang="en-US" sz="1600" dirty="0"/>
           </a:p>
@@ -6134,14 +7509,14 @@
       </p:sp>
       <p:sp>
         <p:nvSpPr>
-          <p:cNvPr id="17" name="Text 15"/>
+          <p:cNvPr id="19" name="Text 16"/>
           <p:cNvSpPr txBox="1"/>
           <p:nvPr/>
         </p:nvSpPr>
         <p:spPr>
           <a:xfrm>
-            <a:off x="457200" y="3840480"/>
-            <a:ext cx="6217920" cy="914400"/>
+            <a:off x="5806440" y="3831336"/>
+            <a:ext cx="2880360" cy="274320"/>
           </a:xfrm>
           <a:prstGeom prst="rect">
             <a:avLst/>
@@ -6153,73 +7528,66 @@
           <a:bodyPr wrap="square" lIns="0" tIns="0" rIns="0" bIns="0" rtlCol="0" anchor="ctr"/>
           <a:lstStyle/>
           <a:p>
-            <a:pPr marL="342900" indent="-342900">
-              <a:spcAft>
-                <a:spcPts val="400"/>
-              </a:spcAft>
-              <a:buSzPct val="100000"/>
-              <a:buChar char="•"/>
-            </a:pPr>
-            <a:r>
-              <a:rPr lang="en-US" sz="1250" dirty="0">
-                <a:solidFill>
-                  <a:srgbClr val="FFFFFF"/>
+            <a:pPr indent="0" marL="0">
+              <a:buNone/>
+            </a:pPr>
+            <a:r>
+              <a:rPr lang="en-US" sz="1250" b="1" dirty="0">
+                <a:solidFill>
+                  <a:srgbClr val="2A1650"/>
                 </a:solidFill>
                 <a:latin typeface="Calibri" pitchFamily="34" charset="0"/>
                 <a:ea typeface="Calibri" pitchFamily="34" charset="-122"/>
                 <a:cs typeface="Calibri" pitchFamily="34" charset="-120"/>
               </a:rPr>
-              <a:t>Agree protection level and engine weights with the PM</a:t>
+              <a:t>No stop-loss as risk control</a:t>
             </a:r>
             <a:endParaRPr lang="en-US" sz="1250" dirty="0"/>
           </a:p>
-          <a:p>
-            <a:pPr marL="342900" indent="-342900">
-              <a:spcAft>
-                <a:spcPts val="400"/>
-              </a:spcAft>
-              <a:buSzPct val="100000"/>
-              <a:buChar char="•"/>
-            </a:pPr>
-            <a:r>
-              <a:rPr lang="en-US" sz="1250" dirty="0">
-                <a:solidFill>
-                  <a:srgbClr val="FFFFFF"/>
+        </p:txBody>
+      </p:sp>
+      <p:sp>
+        <p:nvSpPr>
+          <p:cNvPr id="20" name="Text 17"/>
+          <p:cNvSpPr txBox="1"/>
+          <p:nvPr/>
+        </p:nvSpPr>
+        <p:spPr>
+          <a:xfrm>
+            <a:off x="5806440" y="4105656"/>
+            <a:ext cx="2880360" cy="502920"/>
+          </a:xfrm>
+          <a:prstGeom prst="rect">
+            <a:avLst/>
+          </a:prstGeom>
+          <a:noFill/>
+          <a:ln/>
+        </p:spPr>
+        <p:txBody>
+          <a:bodyPr wrap="square" lIns="0" tIns="0" rIns="0" bIns="0" rtlCol="0" anchor="ctr"/>
+          <a:lstStyle/>
+          <a:p>
+            <a:pPr indent="0" marL="0">
+              <a:buNone/>
+            </a:pPr>
+            <a:r>
+              <a:rPr lang="en-US" sz="1050" dirty="0">
+                <a:solidFill>
+                  <a:srgbClr val="1F1B2D"/>
                 </a:solidFill>
                 <a:latin typeface="Calibri" pitchFamily="34" charset="0"/>
                 <a:ea typeface="Calibri" pitchFamily="34" charset="-122"/>
                 <a:cs typeface="Calibri" pitchFamily="34" charset="-120"/>
               </a:rPr>
-              <a:t>Indicative term sheet within 48 hours, final pricing on trade date</a:t>
-            </a:r>
-            <a:endParaRPr lang="en-US" sz="1250" dirty="0"/>
-          </a:p>
-          <a:p>
-            <a:pPr marL="342900" indent="-342900">
-              <a:spcAft>
-                <a:spcPts val="400"/>
-              </a:spcAft>
-              <a:buSzPct val="100000"/>
-              <a:buChar char="•"/>
-            </a:pPr>
-            <a:r>
-              <a:rPr lang="en-US" sz="1250" dirty="0">
-                <a:solidFill>
-                  <a:srgbClr val="FFFFFF"/>
-                </a:solidFill>
-                <a:latin typeface="Calibri" pitchFamily="34" charset="0"/>
-                <a:ea typeface="Calibri" pitchFamily="34" charset="-122"/>
-                <a:cs typeface="Calibri" pitchFamily="34" charset="-120"/>
-              </a:rPr>
-              <a:t>Natixis provides secondary market and monthly mark-to-market</a:t>
-            </a:r>
-            <a:endParaRPr lang="en-US" sz="1250" dirty="0"/>
-          </a:p>
-        </p:txBody>
-      </p:sp>
-      <p:sp>
-        <p:nvSpPr>
-          <p:cNvPr id="18" name="Text 16"/>
+              <a:t>Max loss is contractual (Unit 15). Any stop triggers on Brent/KOSPI levels, not note price</a:t>
+            </a:r>
+            <a:endParaRPr lang="en-US" sz="1050" dirty="0"/>
+          </a:p>
+        </p:txBody>
+      </p:sp>
+      <p:sp>
+        <p:nvSpPr>
+          <p:cNvPr id="21" name="Text 18"/>
           <p:cNvSpPr txBox="1"/>
           <p:nvPr/>
         </p:nvSpPr>
@@ -7368,7 +8736,7 @@
         <p:spPr>
           <a:xfrm>
             <a:off x="4937760" y="1645920"/>
-            <a:ext cx="3749040" cy="2743200"/>
+            <a:ext cx="3749040" cy="3291840"/>
           </a:xfrm>
           <a:prstGeom prst="rect">
             <a:avLst/>
@@ -7382,13 +8750,13 @@
           <a:p>
             <a:pPr marL="342900" indent="-342900">
               <a:spcAft>
-                <a:spcPts val="600"/>
+                <a:spcPts val="400"/>
               </a:spcAft>
               <a:buSzPct val="100000"/>
               <a:buChar char="•"/>
             </a:pPr>
             <a:r>
-              <a:rPr lang="en-US" sz="1100" dirty="0">
+              <a:rPr lang="en-US" sz="1000" dirty="0">
                 <a:solidFill>
                   <a:srgbClr val="1F1B2D"/>
                 </a:solidFill>
@@ -7398,18 +8766,18 @@
               </a:rPr>
               <a:t>Monte Carlo, 200k paths, daily steps, correlated GBM for Brent, KOSPI 200 and USD/KRW</a:t>
             </a:r>
-            <a:endParaRPr lang="en-US" sz="1100" dirty="0"/>
+            <a:endParaRPr lang="en-US" sz="1000" dirty="0"/>
           </a:p>
           <a:p>
             <a:pPr marL="342900" indent="-342900">
               <a:spcAft>
-                <a:spcPts val="600"/>
+                <a:spcPts val="400"/>
               </a:spcAft>
               <a:buSzPct val="100000"/>
               <a:buChar char="•"/>
             </a:pPr>
             <a:r>
-              <a:rPr lang="en-US" sz="1100" dirty="0">
+              <a:rPr lang="en-US" sz="1000" dirty="0">
                 <a:solidFill>
                   <a:srgbClr val="1F1B2D"/>
                 </a:solidFill>
@@ -7419,18 +8787,18 @@
               </a:rPr>
               <a:t>Placeholder inputs: vols 35% / 22% / 9%; KRW 2.5%, USD 3.75%; KOSPI dividend 1.8%</a:t>
             </a:r>
-            <a:endParaRPr lang="en-US" sz="1100" dirty="0"/>
+            <a:endParaRPr lang="en-US" sz="1000" dirty="0"/>
           </a:p>
           <a:p>
             <a:pPr marL="342900" indent="-342900">
               <a:spcAft>
-                <a:spcPts val="600"/>
+                <a:spcPts val="400"/>
               </a:spcAft>
               <a:buSzPct val="100000"/>
               <a:buChar char="•"/>
             </a:pPr>
             <a:r>
-              <a:rPr lang="en-US" sz="1100" dirty="0">
+              <a:rPr lang="en-US" sz="1000" dirty="0">
                 <a:solidFill>
                   <a:srgbClr val="1F1B2D"/>
                 </a:solidFill>
@@ -7440,18 +8808,18 @@
               </a:rPr>
               <a:t>Engine C priced with skew (130% strike at lower IV)</a:t>
             </a:r>
-            <a:endParaRPr lang="en-US" sz="1100" dirty="0"/>
+            <a:endParaRPr lang="en-US" sz="1000" dirty="0"/>
           </a:p>
           <a:p>
             <a:pPr marL="342900" indent="-342900">
               <a:spcAft>
-                <a:spcPts val="600"/>
+                <a:spcPts val="400"/>
               </a:spcAft>
               <a:buSzPct val="100000"/>
               <a:buChar char="•"/>
             </a:pPr>
             <a:r>
-              <a:rPr lang="en-US" sz="1100" dirty="0">
+              <a:rPr lang="en-US" sz="1000" dirty="0">
                 <a:solidFill>
                   <a:srgbClr val="1F1B2D"/>
                 </a:solidFill>
@@ -7461,7 +8829,49 @@
               </a:rPr>
               <a:t>To finalise: Bloomberg OVDV surfaces, 25-delta risk reversals, realised correlations, CCS basis, local-vol pricing for barriers</a:t>
             </a:r>
-            <a:endParaRPr lang="en-US" sz="1100" dirty="0"/>
+            <a:endParaRPr lang="en-US" sz="1000" dirty="0"/>
+          </a:p>
+          <a:p>
+            <a:pPr marL="342900" indent="-342900">
+              <a:spcAft>
+                <a:spcPts val="400"/>
+              </a:spcAft>
+              <a:buSzPct val="100000"/>
+              <a:buChar char="•"/>
+            </a:pPr>
+            <a:r>
+              <a:rPr lang="en-US" sz="1000" dirty="0">
+                <a:solidFill>
+                  <a:srgbClr val="1F1B2D"/>
+                </a:solidFill>
+                <a:latin typeface="Calibri" pitchFamily="34" charset="0"/>
+                <a:ea typeface="Calibri" pitchFamily="34" charset="-122"/>
+                <a:cs typeface="Calibri" pitchFamily="34" charset="-120"/>
+              </a:rPr>
+              <a:t>Considered and rejected: Korea Value-Up Index as Engine C underlying. Hedge liquidity is far thinner than KOSPI 200 (evidence OI and volume as of 17 Sep 2026)</a:t>
+            </a:r>
+            <a:endParaRPr lang="en-US" sz="1000" dirty="0"/>
+          </a:p>
+          <a:p>
+            <a:pPr marL="342900" indent="-342900">
+              <a:spcAft>
+                <a:spcPts val="400"/>
+              </a:spcAft>
+              <a:buSzPct val="100000"/>
+              <a:buChar char="•"/>
+            </a:pPr>
+            <a:r>
+              <a:rPr lang="en-US" sz="1000" dirty="0">
+                <a:solidFill>
+                  <a:srgbClr val="1F1B2D"/>
+                </a:solidFill>
+                <a:latin typeface="Calibri" pitchFamily="34" charset="0"/>
+                <a:ea typeface="Calibri" pitchFamily="34" charset="-122"/>
+                <a:cs typeface="Calibri" pitchFamily="34" charset="-120"/>
+              </a:rPr>
+              <a:t>Next steps: agree protection level and weights with the PM; indicative term sheet in 48 hours; final pricing on trade date</a:t>
+            </a:r>
+            <a:endParaRPr lang="en-US" sz="1000" dirty="0"/>
           </a:p>
         </p:txBody>
       </p:sp>
@@ -8015,81 +9425,66 @@
         </p:nvSpPr>
         <p:spPr>
           <a:xfrm>
-            <a:off x="457200" y="3657600"/>
-            <a:ext cx="8229600" cy="960120"/>
-          </a:xfrm>
-          <a:prstGeom prst="rect">
-            <a:avLst/>
-          </a:prstGeom>
-          <a:noFill/>
-          <a:ln/>
-        </p:spPr>
-        <p:txBody>
-          <a:bodyPr wrap="square" lIns="0" tIns="0" rIns="0" bIns="0" rtlCol="0" anchor="ctr"/>
+            <a:off x="457200" y="3611880"/>
+            <a:ext cx="8229600" cy="1051560"/>
+          </a:xfrm>
+          <a:prstGeom prst="rect">
+            <a:avLst/>
+          </a:prstGeom>
+          <a:noFill/>
+          <a:ln/>
+        </p:spPr>
+        <p:txBody>
+          <a:bodyPr wrap="square" lIns="0" tIns="0" rIns="0" bIns="0" rtlCol="0" anchor="t"/>
           <a:lstStyle/>
           <a:p>
             <a:pPr indent="0" marL="0">
-              <a:spcAft>
-                <a:spcPts val="300"/>
-              </a:spcAft>
-              <a:buNone/>
-            </a:pPr>
-            <a:r>
-              <a:rPr lang="en-US" sz="1300" b="1" dirty="0">
-                <a:solidFill>
-                  <a:srgbClr val="4B2E83"/>
+              <a:buNone/>
+            </a:pPr>
+            <a:r>
+              <a:rPr lang="en-US" sz="1250" dirty="0">
+                <a:solidFill>
+                  <a:srgbClr val="1F1B2D"/>
                 </a:solidFill>
                 <a:latin typeface="Calibri" pitchFamily="34" charset="0"/>
                 <a:ea typeface="Calibri" pitchFamily="34" charset="-122"/>
                 <a:cs typeface="Calibri" pitchFamily="34" charset="-120"/>
               </a:rPr>
-              <a:t>A  Oil-shock dip buyer: </a:t>
+              <a:t>We recommend </a:t>
             </a:r>
             <a:pPr indent="0" marL="0">
-              <a:spcAft>
-                <a:spcPts val="300"/>
-              </a:spcAft>
-              <a:buNone/>
-            </a:pPr>
-            <a:r>
-              <a:rPr lang="en-US" sz="1300" dirty="0">
-                <a:solidFill>
-                  <a:srgbClr val="1F1B2D"/>
+              <a:buNone/>
+            </a:pPr>
+            <a:r>
+              <a:rPr lang="en-US" sz="1250" b="1" dirty="0">
+                <a:solidFill>
+                  <a:srgbClr val="4B2E83"/>
                 </a:solidFill>
                 <a:latin typeface="Calibri" pitchFamily="34" charset="0"/>
                 <a:ea typeface="Calibri" pitchFamily="34" charset="-122"/>
                 <a:cs typeface="Calibri" pitchFamily="34" charset="-120"/>
               </a:rPr>
-              <a:t>Brent +25% switches on a KOSPI 200 call struck at the dislocated level</a:t>
-            </a:r>
-            <a:endParaRPr lang="en-US" sz="1300" dirty="0"/>
-          </a:p>
-          <a:p>
+              <a:t>an 18-month, 90% capital-protected KRW note</a:t>
+            </a:r>
             <a:pPr indent="0" marL="0">
-              <a:spcAft>
-                <a:spcPts val="300"/>
-              </a:spcAft>
-              <a:buNone/>
-            </a:pPr>
-            <a:r>
-              <a:rPr lang="en-US" sz="1300" b="1" dirty="0">
-                <a:solidFill>
-                  <a:srgbClr val="4B2E83"/>
+              <a:buNone/>
+            </a:pPr>
+            <a:r>
+              <a:rPr lang="en-US" sz="1250" dirty="0">
+                <a:solidFill>
+                  <a:srgbClr val="1F1B2D"/>
                 </a:solidFill>
                 <a:latin typeface="Calibri" pitchFamily="34" charset="0"/>
                 <a:ea typeface="Calibri" pitchFamily="34" charset="-122"/>
                 <a:cs typeface="Calibri" pitchFamily="34" charset="-120"/>
               </a:rPr>
-              <a:t>B  Decoupling dual digital: </a:t>
+              <a:t> on Brent, KOSPI 200 and USD/KRW to express our view that the Iran-war oil shock will dislocate Korean assets, and that structural inflows and reforms will drive the recovery. </a:t>
             </a:r>
             <a:pPr indent="0" marL="0">
-              <a:spcAft>
-                <a:spcPts val="300"/>
-              </a:spcAft>
-              <a:buNone/>
-            </a:pPr>
-            <a:r>
-              <a:rPr lang="en-US" sz="1300" dirty="0">
+              <a:buNone/>
+            </a:pPr>
+            <a:r>
+              <a:rPr lang="en-US" sz="1250" b="1" dirty="0">
                 <a:solidFill>
                   <a:srgbClr val="1F1B2D"/>
                 </a:solidFill>
@@ -8097,46 +9492,9 @@
                 <a:ea typeface="Calibri" pitchFamily="34" charset="-122"/>
                 <a:cs typeface="Calibri" pitchFamily="34" charset="-120"/>
               </a:rPr>
-              <a:t>~9x payout if oil rises and KRW still strengthens</a:t>
-            </a:r>
-            <a:endParaRPr lang="en-US" sz="1300" dirty="0"/>
-          </a:p>
-          <a:p>
-            <a:pPr indent="0" marL="0">
-              <a:spcAft>
-                <a:spcPts val="300"/>
-              </a:spcAft>
-              <a:buNone/>
-            </a:pPr>
-            <a:r>
-              <a:rPr lang="en-US" sz="1300" b="1" dirty="0">
-                <a:solidFill>
-                  <a:srgbClr val="4B2E83"/>
-                </a:solidFill>
-                <a:latin typeface="Calibri" pitchFamily="34" charset="0"/>
-                <a:ea typeface="Calibri" pitchFamily="34" charset="-122"/>
-                <a:cs typeface="Calibri" pitchFamily="34" charset="-120"/>
-              </a:rPr>
-              <a:t>C  Re-rating call spread: </a:t>
-            </a:r>
-            <a:pPr indent="0" marL="0">
-              <a:spcAft>
-                <a:spcPts val="300"/>
-              </a:spcAft>
-              <a:buNone/>
-            </a:pPr>
-            <a:r>
-              <a:rPr lang="en-US" sz="1300" dirty="0">
-                <a:solidFill>
-                  <a:srgbClr val="1F1B2D"/>
-                </a:solidFill>
-                <a:latin typeface="Calibri" pitchFamily="34" charset="0"/>
-                <a:ea typeface="Calibri" pitchFamily="34" charset="-122"/>
-                <a:cs typeface="Calibri" pitchFamily="34" charset="-120"/>
-              </a:rPr>
-              <a:t>KOSPI 200 upside to +30% from ceasefire and Value-up reforms</a:t>
-            </a:r>
-            <a:endParaRPr lang="en-US" sz="1300" dirty="0"/>
+              <a:t>Target redemption: 114–141% in oil-shock regimes, 109.5% in a ceasefire. Maximum loss: 10% (KRW 13.5bn ≈ 10 bp of AUM), contractual.</a:t>
+            </a:r>
+            <a:endParaRPr lang="en-US" sz="1250" dirty="0"/>
           </a:p>
         </p:txBody>
       </p:sp>

</xml_diff>